<commit_message>
Update Oct. 28 PD title and materials
Uses the official title “Strengthening Science Literacy: Calibrating Writing Benchmarks, Feedback, and Revision,” with CUBS + CER as the strategy focus.
</commit_message>
<xml_diff>
--- a/assets/plc/2026-10-28_Science_Department_PD_Strengthening_Science_Literacy.pptx
+++ b/assets/plc/2026-10-28_Science_Department_PD_Strengthening_Science_Literacy.pptx
@@ -1680,8 +1680,8 @@
         </p:nvSpPr>
         <p:spPr>
           <a:xfrm>
-            <a:off x="736600" y="1917700"/>
-            <a:ext cx="11938000" cy="1473200"/>
+            <a:off x="736600" y="1739900"/>
+            <a:ext cx="10985500" cy="1778000"/>
           </a:xfrm>
           <a:prstGeom prst="rect">
             <a:avLst/>
@@ -1697,12 +1697,12 @@
           <a:p>
             <a:pPr algn="l" indent="0" marL="0">
               <a:lnSpc>
-                <a:spcPts val="4644"/>
+                <a:spcPts val="4173"/>
               </a:lnSpc>
               <a:buNone/>
             </a:pPr>
             <a:r>
-              <a:rPr lang="en-US" altLang="en-US" sz="4300" dirty="0">
+              <a:rPr lang="en-US" altLang="en-US" sz="3900" dirty="0">
                 <a:solidFill>
                   <a:srgbClr val="202124"/>
                 </a:solidFill>
@@ -1710,19 +1710,19 @@
                 <a:ea typeface="Inter" pitchFamily="34" charset="-122"/>
                 <a:cs typeface="Inter" pitchFamily="34" charset="-120"/>
               </a:rPr>
-              <a:t>Teaching Students to Analyze</a:t>
-            </a:r>
-            <a:endParaRPr lang="en-US" sz="4300" dirty="0"/>
+              <a:t>Strengthening Science Literacy:</a:t>
+            </a:r>
+            <a:endParaRPr lang="en-US" sz="3900" dirty="0"/>
           </a:p>
           <a:p>
             <a:pPr algn="l" indent="0" marL="0">
               <a:lnSpc>
-                <a:spcPts val="4644"/>
+                <a:spcPts val="4173"/>
               </a:lnSpc>
               <a:buNone/>
             </a:pPr>
             <a:r>
-              <a:rPr lang="en-US" altLang="en-US" sz="4300" dirty="0">
+              <a:rPr lang="en-US" altLang="en-US" sz="3900" dirty="0">
                 <a:solidFill>
                   <a:srgbClr val="202124"/>
                 </a:solidFill>
@@ -1730,9 +1730,29 @@
                 <a:ea typeface="Inter" pitchFamily="34" charset="-122"/>
                 <a:cs typeface="Inter" pitchFamily="34" charset="-120"/>
               </a:rPr>
-              <a:t>Science Texts With CUBS + CER</a:t>
-            </a:r>
-            <a:endParaRPr lang="en-US" sz="4300" dirty="0"/>
+              <a:t>Calibrating Writing Benchmarks,</a:t>
+            </a:r>
+            <a:endParaRPr lang="en-US" sz="3900" dirty="0"/>
+          </a:p>
+          <a:p>
+            <a:pPr algn="l" indent="0" marL="0">
+              <a:lnSpc>
+                <a:spcPts val="4173"/>
+              </a:lnSpc>
+              <a:buNone/>
+            </a:pPr>
+            <a:r>
+              <a:rPr lang="en-US" altLang="en-US" sz="3900" dirty="0">
+                <a:solidFill>
+                  <a:srgbClr val="202124"/>
+                </a:solidFill>
+                <a:latin typeface="Inter" pitchFamily="34" charset="0"/>
+                <a:ea typeface="Inter" pitchFamily="34" charset="-122"/>
+                <a:cs typeface="Inter" pitchFamily="34" charset="-120"/>
+              </a:rPr>
+              <a:t>Feedback, and Revision</a:t>
+            </a:r>
+            <a:endParaRPr lang="en-US" sz="3900" dirty="0"/>
           </a:p>
         </p:txBody>
       </p:sp>
@@ -1744,8 +1764,8 @@
         </p:nvSpPr>
         <p:spPr>
           <a:xfrm>
-            <a:off x="736600" y="3797300"/>
-            <a:ext cx="10820400" cy="1092200"/>
+            <a:off x="736600" y="3848100"/>
+            <a:ext cx="10922000" cy="1320800"/>
           </a:xfrm>
           <a:prstGeom prst="rect">
             <a:avLst/>
@@ -1759,12 +1779,32 @@
           <a:p>
             <a:pPr algn="l" indent="0" marL="0">
               <a:lnSpc>
-                <a:spcPts val="3050"/>
+                <a:spcPts val="2760"/>
               </a:lnSpc>
               <a:buNone/>
             </a:pPr>
             <a:r>
-              <a:rPr lang="en-US" altLang="en-US" sz="2500" dirty="0">
+              <a:rPr lang="en-US" altLang="en-US" sz="2300" b="1" dirty="0">
+                <a:solidFill>
+                  <a:srgbClr val="C41220"/>
+                </a:solidFill>
+                <a:latin typeface="Inter" pitchFamily="34" charset="0"/>
+                <a:ea typeface="Inter" pitchFamily="34" charset="-122"/>
+                <a:cs typeface="Inter" pitchFamily="34" charset="-120"/>
+              </a:rPr>
+              <a:t>Strategy Focus: Teaching Students to Analyze Science Texts With CUBS + CER.</a:t>
+            </a:r>
+            <a:endParaRPr lang="en-US" sz="2300" dirty="0"/>
+          </a:p>
+          <a:p>
+            <a:pPr algn="l" indent="0" marL="0">
+              <a:lnSpc>
+                <a:spcPts val="2760"/>
+              </a:lnSpc>
+              <a:buNone/>
+            </a:pPr>
+            <a:r>
+              <a:rPr lang="en-US" altLang="en-US" sz="2300" dirty="0">
                 <a:solidFill>
                   <a:srgbClr val="3C4043"/>
                 </a:solidFill>
@@ -1772,9 +1812,9 @@
                 <a:ea typeface="Inter" pitchFamily="34" charset="-122"/>
                 <a:cs typeface="Inter" pitchFamily="34" charset="-120"/>
               </a:rPr>
-              <a:t>Learn and rehearse student-facing routines that help students analyze a science article, visual, data display, or text before constructing an evidence-based explanation.</a:t>
-            </a:r>
-            <a:endParaRPr lang="en-US" sz="2500" dirty="0"/>
+              <a:t>Learn and rehearse student-facing routines that prepare students to analyze a science source before constructing and revising an evidence-based explanation.</a:t>
+            </a:r>
+            <a:endParaRPr lang="en-US" sz="2300" dirty="0"/>
           </a:p>
         </p:txBody>
       </p:sp>
@@ -1850,8 +1890,8 @@
         </p:nvSpPr>
         <p:spPr>
           <a:xfrm>
-            <a:off x="12547600" y="3035300"/>
-            <a:ext cx="2590800" cy="1358900"/>
+            <a:off x="12547600" y="2933700"/>
+            <a:ext cx="2590800" cy="1549400"/>
           </a:xfrm>
           <a:prstGeom prst="rect">
             <a:avLst/>
@@ -1865,12 +1905,12 @@
           <a:p>
             <a:pPr algn="ctr" indent="0" marL="0">
               <a:lnSpc>
-                <a:spcPts val="2400"/>
+                <a:spcPts val="2280"/>
               </a:lnSpc>
               <a:buNone/>
             </a:pPr>
             <a:r>
-              <a:rPr lang="en-US" altLang="en-US" sz="2000" dirty="0">
+              <a:rPr lang="en-US" altLang="en-US" sz="1900" dirty="0">
                 <a:solidFill>
                   <a:srgbClr val="3C4043"/>
                 </a:solidFill>
@@ -1878,9 +1918,9 @@
                 <a:ea typeface="Inter" pitchFamily="34" charset="-122"/>
                 <a:cs typeface="Inter" pitchFamily="34" charset="-120"/>
               </a:rPr>
-              <a:t>One ready-to-teach CUBS/CER routine, student directions, and a check for understanding.</a:t>
-            </a:r>
-            <a:endParaRPr lang="en-US" sz="2000" dirty="0"/>
+              <a:t>One calibrated, ready-to-teach CUBS/CER routine with clear student expectations, feedback, revision, and a check for understanding.</a:t>
+            </a:r>
+            <a:endParaRPr lang="en-US" sz="1900" dirty="0"/>
           </a:p>
         </p:txBody>
       </p:sp>
@@ -1917,8 +1957,8 @@
         </p:nvSpPr>
         <p:spPr>
           <a:xfrm>
-            <a:off x="1117600" y="6172200"/>
-            <a:ext cx="13919200" cy="787400"/>
+            <a:off x="1117600" y="6096000"/>
+            <a:ext cx="13919200" cy="952500"/>
           </a:xfrm>
           <a:prstGeom prst="rect">
             <a:avLst/>
@@ -1932,12 +1972,12 @@
           <a:p>
             <a:pPr algn="l" indent="0" marL="0">
               <a:lnSpc>
-                <a:spcPts val="2684"/>
+                <a:spcPts val="2520"/>
               </a:lnSpc>
               <a:buNone/>
             </a:pPr>
             <a:r>
-              <a:rPr lang="en-US" altLang="en-US" sz="2200" b="1" dirty="0">
+              <a:rPr lang="en-US" altLang="en-US" sz="2100" b="1" dirty="0">
                 <a:solidFill>
                   <a:srgbClr val="C41220"/>
                 </a:solidFill>
@@ -1948,7 +1988,7 @@
               <a:t>The shared model is Biology Benchmark #1.</a:t>
             </a:r>
             <a:r>
-              <a:rPr lang="en-US" altLang="en-US" sz="2200" dirty="0">
+              <a:rPr lang="en-US" altLang="en-US" sz="2100" dirty="0">
                 <a:solidFill>
                   <a:srgbClr val="3C4043"/>
                 </a:solidFill>
@@ -1956,9 +1996,9 @@
                 <a:ea typeface="Inter" pitchFamily="34" charset="-122"/>
                 <a:cs typeface="Inter" pitchFamily="34" charset="-120"/>
               </a:rPr>
-              <a:t> Each science team will adapt the strategy to an appropriate article, text, data display, model, investigation prompt, or constructed-response task.</a:t>
-            </a:r>
-            <a:endParaRPr lang="en-US" sz="2200" dirty="0"/>
+              <a:t> Teams will calibrate the writing benchmark, student-facing CUBS/CER routine, feedback prompt, and revision action, then adapt the strategy to an appropriate course task.</a:t>
+            </a:r>
+            <a:endParaRPr lang="en-US" sz="2100" dirty="0"/>
           </a:p>
         </p:txBody>
       </p:sp>
@@ -2156,7 +2196,7 @@
                 <a:ea typeface="Inter" pitchFamily="34" charset="-122"/>
                 <a:cs typeface="Inter" pitchFamily="34" charset="-120"/>
               </a:rPr>
-              <a:t>A Practical Outcome for Today</a:t>
+              <a:t>Calibrate the Benchmark-to-Revision Path</a:t>
             </a:r>
             <a:endParaRPr lang="en-US" sz="3000" dirty="0"/>
           </a:p>
@@ -2237,7 +2277,7 @@
                 <a:ea typeface="Inter" pitchFamily="34" charset="-122"/>
                 <a:cs typeface="Inter" pitchFamily="34" charset="-120"/>
               </a:rPr>
-              <a:t>Leave with a clear, student-facing way to move from reading/analyzing a source to constructing, color-coding, and revising a science Claim–Evidence–Reasoning response.</a:t>
+              <a:t>Use one shared writing benchmark to align the student path from source analysis to a complete evidence-based CER response, criterion-based feedback, and a revision students can act on.</a:t>
             </a:r>
             <a:endParaRPr lang="en-US" sz="2300" dirty="0"/>
           </a:p>
@@ -2515,7 +2555,7 @@
                 <a:ea typeface="Inter" pitchFamily="34" charset="-122"/>
                 <a:cs typeface="Inter" pitchFamily="34" charset="-120"/>
               </a:rPr>
-              <a:t>Practice on a source</a:t>
+              <a:t>Rehearse the source</a:t>
             </a:r>
             <a:endParaRPr lang="en-US" sz="2000" dirty="0"/>
           </a:p>
@@ -2603,7 +2643,7 @@
                 <a:ea typeface="Inter" pitchFamily="34" charset="-122"/>
                 <a:cs typeface="Inter" pitchFamily="34" charset="-120"/>
               </a:rPr>
-              <a:t>Model CER colors</a:t>
+              <a:t>Calibrate CER quality</a:t>
             </a:r>
             <a:endParaRPr lang="en-US" sz="2000" dirty="0"/>
           </a:p>
@@ -2691,7 +2731,7 @@
                 <a:ea typeface="Inter" pitchFamily="34" charset="-122"/>
                 <a:cs typeface="Inter" pitchFamily="34" charset="-120"/>
               </a:rPr>
-              <a:t>Adapt the routine</a:t>
+              <a:t>Plan feedback + revision</a:t>
             </a:r>
             <a:endParaRPr lang="en-US" sz="2000" dirty="0"/>
           </a:p>
@@ -2714,7 +2754,7 @@
                 <a:ea typeface="Inter" pitchFamily="34" charset="-122"/>
                 <a:cs typeface="Inter" pitchFamily="34" charset="-120"/>
               </a:rPr>
-              <a:t>Write student directions and a check for understanding.</a:t>
+              <a:t>Write student directions, a feedback prompt, and an action.</a:t>
             </a:r>
             <a:endParaRPr lang="en-US" sz="2000" dirty="0"/>
           </a:p>
@@ -2802,7 +2842,7 @@
                 <a:ea typeface="Inter" pitchFamily="34" charset="-122"/>
                 <a:cs typeface="Inter" pitchFamily="34" charset="-120"/>
               </a:rPr>
-              <a:t>Collect completed writing for Friday’s feedback and next-step work.</a:t>
+              <a:t>Collect completed writing for Friday’s feedback and mastery work.</a:t>
             </a:r>
             <a:endParaRPr lang="en-US" sz="2000" dirty="0"/>
           </a:p>
@@ -3025,7 +3065,7 @@
                 <a:ea typeface="Inter" pitchFamily="34" charset="-122"/>
                 <a:cs typeface="Inter" pitchFamily="34" charset="-120"/>
               </a:rPr>
-              <a:t>The Same Benchmark, Now With a Teachable Routine</a:t>
+              <a:t>Calibrate the Benchmark-to-Revision Cycle</a:t>
             </a:r>
             <a:endParaRPr lang="en-US" sz="3000" dirty="0"/>
           </a:p>
@@ -3103,7 +3143,7 @@
                 <a:ea typeface="Inter" pitchFamily="34" charset="-122"/>
                 <a:cs typeface="Inter" pitchFamily="34" charset="-120"/>
               </a:rPr>
-              <a:t>The strategy is not an add-on: it helps students do the same source analysis and evidence-based writing teachers rehearsed Monday and planned Tuesday.</a:t>
+              <a:t>CUBS/CER is the strategy focus within the larger work: calibrating the writing benchmark, expected student thinking, feedback, and revision before Friday’s evidence review.</a:t>
             </a:r>
             <a:endParaRPr lang="en-US" sz="2300" dirty="0"/>
           </a:p>
@@ -3497,7 +3537,7 @@
                 <a:ea typeface="Inter" pitchFamily="34" charset="-122"/>
                 <a:cs typeface="Inter" pitchFamily="34" charset="-120"/>
               </a:rPr>
-              <a:t>Teach CUBS + CER</a:t>
+              <a:t>Calibrate CUBS + CER</a:t>
             </a:r>
             <a:endParaRPr lang="en-US" sz="2000" dirty="0"/>
           </a:p>
@@ -3520,7 +3560,7 @@
                 <a:ea typeface="Inter" pitchFamily="34" charset="-122"/>
                 <a:cs typeface="Inter" pitchFamily="34" charset="-120"/>
               </a:rPr>
-              <a:t>Model and adapt the student routine for an authentic science source/task.</a:t>
+              <a:t>Use the routine to align expectations for feedback and revision.</a:t>
             </a:r>
             <a:endParaRPr lang="en-US" sz="2000" dirty="0"/>
           </a:p>
@@ -5792,7 +5832,7 @@
                 <a:ea typeface="Inter" pitchFamily="34" charset="-122"/>
                 <a:cs typeface="Inter" pitchFamily="34" charset="-120"/>
               </a:rPr>
-              <a:t>Teach the Routine—Do Not Complete the Thinking</a:t>
+              <a:t>Calibrate Feedback That Prompts Revision</a:t>
             </a:r>
             <a:endParaRPr lang="en-US" sz="3000" dirty="0"/>
           </a:p>
@@ -5870,7 +5910,7 @@
                 <a:ea typeface="Inter" pitchFamily="34" charset="-122"/>
                 <a:cs typeface="Inter" pitchFamily="34" charset="-120"/>
               </a:rPr>
-              <a:t>Use explicit modeling, student practice, and feedback that sends students back to the source and their own response. The routine should increase—not replace—student analysis.</a:t>
+              <a:t>Agree on one student action after feedback. Use explicit modeling, practice, and a prompt that sends students back to the source and their own response without completing the thinking.</a:t>
             </a:r>
             <a:endParaRPr lang="en-US" sz="2300" dirty="0"/>
           </a:p>
@@ -6194,7 +6234,7 @@
                 <a:ea typeface="Inter" pitchFamily="34" charset="-122"/>
                 <a:cs typeface="Inter" pitchFamily="34" charset="-120"/>
               </a:rPr>
-              <a:t>Students act on one criterion-based written feedback prompt.</a:t>
+              <a:t>Students act on one calibrated, criterion-based written feedback prompt.</a:t>
             </a:r>
             <a:endParaRPr lang="en-US" sz="2000" dirty="0"/>
           </a:p>
@@ -6567,7 +6607,7 @@
                 <a:ea typeface="Inter" pitchFamily="34" charset="-122"/>
                 <a:cs typeface="Inter" pitchFamily="34" charset="-120"/>
               </a:rPr>
-              <a:t>Protected Course-Alike Application</a:t>
+              <a:t>Protected Course-Alike Calibration + Application</a:t>
             </a:r>
             <a:endParaRPr lang="en-US" sz="3000" dirty="0"/>
           </a:p>
@@ -6835,7 +6875,7 @@
                 <a:ea typeface="Inter" pitchFamily="34" charset="-122"/>
                 <a:cs typeface="Inter" pitchFamily="34" charset="-120"/>
               </a:rPr>
-              <a:t>1. Choose the source/task.</a:t>
+              <a:t>1. Choose the writing benchmark/source/task.</a:t>
             </a:r>
             <a:r>
               <a:rPr lang="en-US" altLang="en-US" sz="2100" dirty="0">
@@ -6913,7 +6953,7 @@
                 <a:ea typeface="Inter" pitchFamily="34" charset="-122"/>
                 <a:cs typeface="Inter" pitchFamily="34" charset="-120"/>
               </a:rPr>
-              <a:t>2. Write the student directions.</a:t>
+              <a:t>2. Calibrate the student expectations.</a:t>
             </a:r>
             <a:r>
               <a:rPr lang="en-US" altLang="en-US" sz="2100" dirty="0">
@@ -6924,7 +6964,7 @@
                 <a:ea typeface="Inter" pitchFamily="34" charset="-122"/>
                 <a:cs typeface="Inter" pitchFamily="34" charset="-120"/>
               </a:rPr>
-              <a:t> Specify what students will CUBS, what they will identify or color-code in CER, and what they will do with the annotation.</a:t>
+              <a:t> Specify what students will CUBS, what they will identify or color-code in CER, and what the response must show to meet the mastery bar.</a:t>
             </a:r>
             <a:endParaRPr lang="en-US" sz="2100" dirty="0"/>
           </a:p>
@@ -6991,7 +7031,7 @@
                 <a:ea typeface="Inter" pitchFamily="34" charset="-122"/>
                 <a:cs typeface="Inter" pitchFamily="34" charset="-120"/>
               </a:rPr>
-              <a:t>3. Plan a check + feedback step.</a:t>
+              <a:t>3. Plan feedback + revision.</a:t>
             </a:r>
             <a:r>
               <a:rPr lang="en-US" altLang="en-US" sz="2100" dirty="0">
@@ -7002,7 +7042,7 @@
                 <a:ea typeface="Inter" pitchFamily="34" charset="-122"/>
                 <a:cs typeface="Inter" pitchFamily="34" charset="-120"/>
               </a:rPr>
-              <a:t> Name the prompt, partner talk, annotation check, or short response that will reveal student thinking and lead to a written-feedback/revision opportunity.</a:t>
+              <a:t> Name the prompt, partner talk, annotation check, or short response that reveals thinking, then write a criterion-based feedback prompt and the revision students will complete.</a:t>
             </a:r>
             <a:endParaRPr lang="en-US" sz="2100" dirty="0"/>
           </a:p>
@@ -7167,23 +7207,25 @@
         <p:spPr>
           <a:xfrm>
             <a:off x="736600" y="1689100"/>
-            <a:ext cx="13208000" cy="787400"/>
-          </a:xfrm>
-          <a:prstGeom prst="rect">
-            <a:avLst/>
-          </a:prstGeom>
-          <a:noFill/>
-          <a:ln/>
-        </p:spPr>
-        <p:txBody>
-          <a:bodyPr wrap="square" lIns="0" tIns="0" rIns="0" bIns="0" rtlCol="0" anchor="t"/>
-          <a:lstStyle/>
-          <a:p>
-            <a:pPr algn="l" indent="0" marL="0">
-              <a:buNone/>
-            </a:pPr>
-            <a:r>
-              <a:rPr lang="en-US" altLang="en-US" sz="4300" dirty="0">
+            <a:ext cx="13843000" cy="787400"/>
+          </a:xfrm>
+          <a:prstGeom prst="rect">
+            <a:avLst/>
+          </a:prstGeom>
+          <a:noFill/>
+          <a:ln/>
+        </p:spPr>
+        <p:txBody>
+          <a:bodyPr wrap="square" lIns="0" tIns="0" rIns="0" bIns="0" rtlCol="0" anchor="t">
+            <a:normAutofit/>
+          </a:bodyPr>
+          <a:lstStyle/>
+          <a:p>
+            <a:pPr algn="l" indent="0" marL="0">
+              <a:buNone/>
+            </a:pPr>
+            <a:r>
+              <a:rPr lang="en-US" altLang="en-US" sz="3900" dirty="0">
                 <a:solidFill>
                   <a:srgbClr val="202124"/>
                 </a:solidFill>
@@ -7191,9 +7233,9 @@
                 <a:ea typeface="Inter" pitchFamily="34" charset="-122"/>
                 <a:cs typeface="Inter" pitchFamily="34" charset="-120"/>
               </a:rPr>
-              <a:t>Use the routine. Collect completed writing. Return Friday.</a:t>
-            </a:r>
-            <a:endParaRPr lang="en-US" sz="4300" dirty="0"/>
+              <a:t>Implement the routine. Collect writing. Revisit feedback and revision Friday.</a:t>
+            </a:r>
+            <a:endParaRPr lang="en-US" sz="3900" dirty="0"/>
           </a:p>
         </p:txBody>
       </p:sp>
@@ -7421,7 +7463,7 @@
                 <a:ea typeface="Inter" pitchFamily="34" charset="-122"/>
                 <a:cs typeface="Inter" pitchFamily="34" charset="-120"/>
               </a:rPr>
-              <a:t>Bring a small de-identified set of completed student writing and notes on written feedback.</a:t>
+              <a:t>Bring a small de-identified set of completed writing and the feedback/revision evidence from the task.</a:t>
             </a:r>
             <a:endParaRPr lang="en-US" sz="2000" dirty="0"/>
           </a:p>

</xml_diff>

<commit_message>
Finalize Oct. 28 Science Literacy PD materials
Update the all-science-course PD deck and one-page agenda; add the LIT-aligned reflection and next-steps sheet in printable and editable formats; include CUBS, color-coded CER, de-identified writing-sample analysis, and teacher strategy sharing.
</commit_message>
<xml_diff>
--- a/assets/plc/2026-10-28_Science_Department_PD_Strengthening_Science_Literacy.pptx
+++ b/assets/plc/2026-10-28_Science_Department_PD_Strengthening_Science_Literacy.pptx
@@ -1642,7 +1642,7 @@
         <p:spPr>
           <a:xfrm>
             <a:off x="736600" y="381000"/>
-            <a:ext cx="12700000" cy="279400"/>
+            <a:ext cx="13462000" cy="279400"/>
           </a:xfrm>
           <a:prstGeom prst="rect">
             <a:avLst/>
@@ -1765,7 +1765,7 @@
         <p:spPr>
           <a:xfrm>
             <a:off x="736600" y="3848100"/>
-            <a:ext cx="10922000" cy="1320800"/>
+            <a:ext cx="10922000" cy="1422400"/>
           </a:xfrm>
           <a:prstGeom prst="rect">
             <a:avLst/>
@@ -1779,12 +1779,12 @@
           <a:p>
             <a:pPr algn="l" indent="0" marL="0">
               <a:lnSpc>
-                <a:spcPts val="2760"/>
+                <a:spcPts val="2640"/>
               </a:lnSpc>
               <a:buNone/>
             </a:pPr>
             <a:r>
-              <a:rPr lang="en-US" altLang="en-US" sz="2300" b="1" dirty="0">
+              <a:rPr lang="en-US" altLang="en-US" sz="2200" b="1" dirty="0">
                 <a:solidFill>
                   <a:srgbClr val="C41220"/>
                 </a:solidFill>
@@ -1792,19 +1792,19 @@
                 <a:ea typeface="Inter" pitchFamily="34" charset="-122"/>
                 <a:cs typeface="Inter" pitchFamily="34" charset="-120"/>
               </a:rPr>
-              <a:t>Strategy Focus: Teaching Students to Analyze Science Texts With CUBS + CER.</a:t>
-            </a:r>
-            <a:endParaRPr lang="en-US" sz="2300" dirty="0"/>
+              <a:t>Strategy Focus: Teaching Students to Analyze Science Sources With CUBS + CER.</a:t>
+            </a:r>
+            <a:endParaRPr lang="en-US" sz="2200" dirty="0"/>
           </a:p>
           <a:p>
             <a:pPr algn="l" indent="0" marL="0">
               <a:lnSpc>
-                <a:spcPts val="2760"/>
+                <a:spcPts val="2640"/>
               </a:lnSpc>
               <a:buNone/>
             </a:pPr>
             <a:r>
-              <a:rPr lang="en-US" altLang="en-US" sz="2300" dirty="0">
+              <a:rPr lang="en-US" altLang="en-US" sz="2200" dirty="0">
                 <a:solidFill>
                   <a:srgbClr val="3C4043"/>
                 </a:solidFill>
@@ -1812,9 +1812,9 @@
                 <a:ea typeface="Inter" pitchFamily="34" charset="-122"/>
                 <a:cs typeface="Inter" pitchFamily="34" charset="-120"/>
               </a:rPr>
-              <a:t>Learn and rehearse student-facing routines that prepare students to analyze a science source before constructing and revising an evidence-based explanation.</a:t>
-            </a:r>
-            <a:endParaRPr lang="en-US" sz="2300" dirty="0"/>
+              <a:t>Use adaptable student-facing routines to help students notice, explain, and revise their thinking from a text, data display, diagram, model, investigation result, or other course source.</a:t>
+            </a:r>
+            <a:endParaRPr lang="en-US" sz="2200" dirty="0"/>
           </a:p>
         </p:txBody>
       </p:sp>
@@ -1827,7 +1827,7 @@
         <p:spPr>
           <a:xfrm>
             <a:off x="12242800" y="2057400"/>
-            <a:ext cx="3200400" cy="2984500"/>
+            <a:ext cx="3200400" cy="3073400"/>
           </a:xfrm>
           <a:prstGeom prst="rect">
             <a:avLst/>
@@ -1891,7 +1891,7 @@
         <p:spPr>
           <a:xfrm>
             <a:off x="12547600" y="2933700"/>
-            <a:ext cx="2590800" cy="1549400"/>
+            <a:ext cx="2590800" cy="1714500"/>
           </a:xfrm>
           <a:prstGeom prst="rect">
             <a:avLst/>
@@ -1918,7 +1918,7 @@
                 <a:ea typeface="Inter" pitchFamily="34" charset="-122"/>
                 <a:cs typeface="Inter" pitchFamily="34" charset="-120"/>
               </a:rPr>
-              <a:t>One calibrated, ready-to-teach CUBS/CER routine with clear student expectations, feedback, revision, and a check for understanding.</a:t>
+              <a:t>One course-ready CUBS/CER routine with clear student directions, a feedback and revision action, an evidence check, and a recorded next step.</a:t>
             </a:r>
             <a:endParaRPr lang="en-US" sz="1900" dirty="0"/>
           </a:p>
@@ -1932,8 +1932,8 @@
         </p:nvSpPr>
         <p:spPr>
           <a:xfrm>
-            <a:off x="736600" y="5842000"/>
-            <a:ext cx="14706600" cy="1422400"/>
+            <a:off x="736600" y="5994400"/>
+            <a:ext cx="14706600" cy="1295400"/>
           </a:xfrm>
           <a:prstGeom prst="rect">
             <a:avLst/>
@@ -1957,8 +1957,8 @@
         </p:nvSpPr>
         <p:spPr>
           <a:xfrm>
-            <a:off x="1117600" y="6096000"/>
-            <a:ext cx="13919200" cy="952500"/>
+            <a:off x="1117600" y="6248400"/>
+            <a:ext cx="13919200" cy="838200"/>
           </a:xfrm>
           <a:prstGeom prst="rect">
             <a:avLst/>
@@ -1972,12 +1972,12 @@
           <a:p>
             <a:pPr algn="l" indent="0" marL="0">
               <a:lnSpc>
-                <a:spcPts val="2520"/>
+                <a:spcPts val="2400"/>
               </a:lnSpc>
               <a:buNone/>
             </a:pPr>
             <a:r>
-              <a:rPr lang="en-US" altLang="en-US" sz="2100" b="1" dirty="0">
+              <a:rPr lang="en-US" altLang="en-US" sz="2000" b="1" dirty="0">
                 <a:solidFill>
                   <a:srgbClr val="C41220"/>
                 </a:solidFill>
@@ -1985,10 +1985,10 @@
                 <a:ea typeface="Inter" pitchFamily="34" charset="-122"/>
                 <a:cs typeface="Inter" pitchFamily="34" charset="-120"/>
               </a:rPr>
-              <a:t>The shared model is Biology Benchmark #1.</a:t>
-            </a:r>
-            <a:r>
-              <a:rPr lang="en-US" altLang="en-US" sz="2100" dirty="0">
+              <a:t>Bring an authentic course source/task and 1–2 de-identified writing samples.</a:t>
+            </a:r>
+            <a:r>
+              <a:rPr lang="en-US" altLang="en-US" sz="2000" dirty="0">
                 <a:solidFill>
                   <a:srgbClr val="3C4043"/>
                 </a:solidFill>
@@ -1996,9 +1996,9 @@
                 <a:ea typeface="Inter" pitchFamily="34" charset="-122"/>
                 <a:cs typeface="Inter" pitchFamily="34" charset="-120"/>
               </a:rPr>
-              <a:t> Teams will calibrate the writing benchmark, student-facing CUBS/CER routine, feedback prompt, and revision action, then adapt the strategy to an appropriate course task.</a:t>
-            </a:r>
-            <a:endParaRPr lang="en-US" sz="2100" dirty="0"/>
+              <a:t> The Biology benchmark is optional; each teacher will adapt the routine and use samples to calibrate student thinking, feedback, and revision.</a:t>
+            </a:r>
+            <a:endParaRPr lang="en-US" sz="2000" dirty="0"/>
           </a:p>
         </p:txBody>
       </p:sp>
@@ -2011,7 +2011,7 @@
         <p:spPr>
           <a:xfrm>
             <a:off x="736600" y="7975600"/>
-            <a:ext cx="12827000" cy="431800"/>
+            <a:ext cx="13208000" cy="431800"/>
           </a:xfrm>
           <a:prstGeom prst="rect">
             <a:avLst/>
@@ -2196,7 +2196,7 @@
                 <a:ea typeface="Inter" pitchFamily="34" charset="-122"/>
                 <a:cs typeface="Inter" pitchFamily="34" charset="-120"/>
               </a:rPr>
-              <a:t>Calibrate the Benchmark-to-Revision Path</a:t>
+              <a:t>Calibrate a Transferable Science Literacy Routine</a:t>
             </a:r>
             <a:endParaRPr lang="en-US" sz="3000" dirty="0"/>
           </a:p>
@@ -2277,7 +2277,7 @@
                 <a:ea typeface="Inter" pitchFamily="34" charset="-122"/>
                 <a:cs typeface="Inter" pitchFamily="34" charset="-120"/>
               </a:rPr>
-              <a:t>Use one shared writing benchmark to align the student path from source analysis to a complete evidence-based CER response, criterion-based feedback, and a revision students can act on.</a:t>
+              <a:t>Use an authentic course source, response task, and de-identified writing samples to align what students notice, explain, revise, and show as evidence of standards-aligned science learning.</a:t>
             </a:r>
             <a:endParaRPr lang="en-US" sz="2300" dirty="0"/>
           </a:p>
@@ -2467,7 +2467,7 @@
                 <a:ea typeface="Inter" pitchFamily="34" charset="-122"/>
                 <a:cs typeface="Inter" pitchFamily="34" charset="-120"/>
               </a:rPr>
-              <a:t>Model CUBS</a:t>
+              <a:t>Choose the source + task</a:t>
             </a:r>
             <a:endParaRPr lang="en-US" sz="2000" dirty="0"/>
           </a:p>
@@ -2490,7 +2490,7 @@
                 <a:ea typeface="Inter" pitchFamily="34" charset="-122"/>
                 <a:cs typeface="Inter" pitchFamily="34" charset="-120"/>
               </a:rPr>
-              <a:t>Make the source-analysis moves visible.</a:t>
+              <a:t>Use a text, graph, data set, diagram, model, lab result, or scenario.</a:t>
             </a:r>
             <a:endParaRPr lang="en-US" sz="2000" dirty="0"/>
           </a:p>
@@ -2555,7 +2555,7 @@
                 <a:ea typeface="Inter" pitchFamily="34" charset="-122"/>
                 <a:cs typeface="Inter" pitchFamily="34" charset="-120"/>
               </a:rPr>
-              <a:t>Rehearse the source</a:t>
+              <a:t>Make noticing visible</a:t>
             </a:r>
             <a:endParaRPr lang="en-US" sz="2000" dirty="0"/>
           </a:p>
@@ -2578,7 +2578,7 @@
                 <a:ea typeface="Inter" pitchFamily="34" charset="-122"/>
                 <a:cs typeface="Inter" pitchFamily="34" charset="-120"/>
               </a:rPr>
-              <a:t>Annotate a science text, visual, or data display.</a:t>
+              <a:t>Rehearse CUBS or another access routine before students write.</a:t>
             </a:r>
             <a:endParaRPr lang="en-US" sz="2000" dirty="0"/>
           </a:p>
@@ -2666,7 +2666,7 @@
                 <a:ea typeface="Inter" pitchFamily="34" charset="-122"/>
                 <a:cs typeface="Inter" pitchFamily="34" charset="-120"/>
               </a:rPr>
-              <a:t>See claim, evidence, reasoning, and transitions.</a:t>
+              <a:t>Clarify claim, evidence, reasoning, and links to the science idea.</a:t>
             </a:r>
             <a:endParaRPr lang="en-US" sz="2000" dirty="0"/>
           </a:p>
@@ -2754,7 +2754,7 @@
                 <a:ea typeface="Inter" pitchFamily="34" charset="-122"/>
                 <a:cs typeface="Inter" pitchFamily="34" charset="-120"/>
               </a:rPr>
-              <a:t>Write student directions, a feedback prompt, and an action.</a:t>
+              <a:t>Write a prompt and a specific action students will take.</a:t>
             </a:r>
             <a:endParaRPr lang="en-US" sz="2000" dirty="0"/>
           </a:p>
@@ -2819,7 +2819,7 @@
                 <a:ea typeface="Inter" pitchFamily="34" charset="-122"/>
                 <a:cs typeface="Inter" pitchFamily="34" charset="-120"/>
               </a:rPr>
-              <a:t>Use the evidence</a:t>
+              <a:t>Share, reflect + commit</a:t>
             </a:r>
             <a:endParaRPr lang="en-US" sz="2000" dirty="0"/>
           </a:p>
@@ -2842,7 +2842,7 @@
                 <a:ea typeface="Inter" pitchFamily="34" charset="-122"/>
                 <a:cs typeface="Inter" pitchFamily="34" charset="-120"/>
               </a:rPr>
-              <a:t>Collect completed writing for Friday’s feedback and mastery work.</a:t>
+              <a:t>Learn from colleague strategies, read samples, and record a feedback-informed next move.</a:t>
             </a:r>
             <a:endParaRPr lang="en-US" sz="2000" dirty="0"/>
           </a:p>
@@ -2915,7 +2915,7 @@
                 <a:ea typeface="Inter" pitchFamily="34" charset="-122"/>
                 <a:cs typeface="Inter" pitchFamily="34" charset="-120"/>
               </a:rPr>
-              <a:t> Use it to help students do the task; do not turn it into a separate graded assignment.</a:t>
+              <a:t> Adapt the source and product; keep students responsible for the science reasoning.</a:t>
             </a:r>
             <a:endParaRPr lang="en-US" sz="2100" dirty="0"/>
           </a:p>
@@ -3065,7 +3065,7 @@
                 <a:ea typeface="Inter" pitchFamily="34" charset="-122"/>
                 <a:cs typeface="Inter" pitchFamily="34" charset="-120"/>
               </a:rPr>
-              <a:t>Calibrate the Benchmark-to-Revision Cycle</a:t>
+              <a:t>One Evidence-to-Action Cycle, Multiple Science Contexts</a:t>
             </a:r>
             <a:endParaRPr lang="en-US" sz="3000" dirty="0"/>
           </a:p>
@@ -3143,7 +3143,7 @@
                 <a:ea typeface="Inter" pitchFamily="34" charset="-122"/>
                 <a:cs typeface="Inter" pitchFamily="34" charset="-120"/>
               </a:rPr>
-              <a:t>CUBS/CER is the strategy focus within the larger work: calibrating the writing benchmark, expected student thinking, feedback, and revision before Friday’s evidence review.</a:t>
+              <a:t>The Biology benchmark was a shared learning model. Today, every teacher applies the same source-analysis, explanation, feedback, and revision cycle to an authentic task in the course they teach.</a:t>
             </a:r>
             <a:endParaRPr lang="en-US" sz="2300" dirty="0"/>
           </a:p>
@@ -3233,7 +3233,7 @@
                 <a:ea typeface="Inter" pitchFamily="34" charset="-122"/>
                 <a:cs typeface="Inter" pitchFamily="34" charset="-120"/>
               </a:rPr>
-              <a:t>Experience the task</a:t>
+              <a:t>Experience a task</a:t>
             </a:r>
             <a:endParaRPr lang="en-US" sz="2000" dirty="0"/>
           </a:p>
@@ -3256,7 +3256,7 @@
                 <a:ea typeface="Inter" pitchFamily="34" charset="-122"/>
                 <a:cs typeface="Inter" pitchFamily="34" charset="-120"/>
               </a:rPr>
-              <a:t>Teachers completed and analyzed the benchmark as students.</a:t>
+              <a:t>Use a common benchmark model to see the learner demand.</a:t>
             </a:r>
             <a:endParaRPr lang="en-US" sz="2000" dirty="0"/>
           </a:p>
@@ -3408,7 +3408,7 @@
                 <a:ea typeface="Inter" pitchFamily="34" charset="-122"/>
                 <a:cs typeface="Inter" pitchFamily="34" charset="-120"/>
               </a:rPr>
-              <a:t>Teams planned access, facilitation, feedback, and revision.</a:t>
+              <a:t>Plan access, facilitation, feedback, and revision for your course.</a:t>
             </a:r>
             <a:endParaRPr lang="en-US" sz="2000" dirty="0"/>
           </a:p>
@@ -3537,7 +3537,7 @@
                 <a:ea typeface="Inter" pitchFamily="34" charset="-122"/>
                 <a:cs typeface="Inter" pitchFamily="34" charset="-120"/>
               </a:rPr>
-              <a:t>Calibrate CUBS + CER</a:t>
+              <a:t>Adapt CUBS + CER</a:t>
             </a:r>
             <a:endParaRPr lang="en-US" sz="2000" dirty="0"/>
           </a:p>
@@ -3560,7 +3560,7 @@
                 <a:ea typeface="Inter" pitchFamily="34" charset="-122"/>
                 <a:cs typeface="Inter" pitchFamily="34" charset="-120"/>
               </a:rPr>
-              <a:t>Use the routine to align expectations for feedback and revision.</a:t>
+              <a:t>Teach students how to analyze sources and explain evidence.</a:t>
             </a:r>
             <a:endParaRPr lang="en-US" sz="2000" dirty="0"/>
           </a:p>
@@ -3707,7 +3707,7 @@
                 <a:ea typeface="Inter" pitchFamily="34" charset="-122"/>
                 <a:cs typeface="Inter" pitchFamily="34" charset="-120"/>
               </a:rPr>
-              <a:t>Analyze completed student work, provide written feedback, and plan a precise mastery next step.</a:t>
+              <a:t>Use completed course-specific work to provide feedback and plan a precise mastery next step.</a:t>
             </a:r>
             <a:endParaRPr lang="en-US" sz="2000" dirty="0"/>
           </a:p>
@@ -3774,7 +3774,7 @@
                 <a:ea typeface="Inter" pitchFamily="34" charset="-122"/>
                 <a:cs typeface="Inter" pitchFamily="34" charset="-120"/>
               </a:rPr>
-              <a:t>Keep the work transferable:</a:t>
+              <a:t>Keep the process common and the science authentic:</a:t>
             </a:r>
             <a:r>
               <a:rPr lang="en-US" altLang="en-US" sz="2100" dirty="0">
@@ -3785,7 +3785,7 @@
                 <a:ea typeface="Inter" pitchFamily="34" charset="-122"/>
                 <a:cs typeface="Inter" pitchFamily="34" charset="-120"/>
               </a:rPr>
-              <a:t> all high-school science teachers adapt the routine to their own course task while holding the same expectations for evidence-based thinking.</a:t>
+              <a:t> the routine can support Biology, Chemistry, Physics, Environmental Science, and every other science course.</a:t>
             </a:r>
             <a:endParaRPr lang="en-US" sz="2100" dirty="0"/>
           </a:p>
@@ -3935,7 +3935,7 @@
                 <a:ea typeface="Inter" pitchFamily="34" charset="-122"/>
                 <a:cs typeface="Inter" pitchFamily="34" charset="-120"/>
               </a:rPr>
-              <a:t>Model CUBS: Analyze the Source Before Writing</a:t>
+              <a:t>Model CUBS: Analyze a Science Source Before Writing</a:t>
             </a:r>
             <a:endParaRPr lang="en-US" sz="3000" dirty="0"/>
           </a:p>
@@ -4038,7 +4038,7 @@
                 <a:ea typeface="Inter" pitchFamily="34" charset="-122"/>
                 <a:cs typeface="Inter" pitchFamily="34" charset="-120"/>
               </a:rPr>
-              <a:t>Think aloud: make the reading, visual-analysis, vocabulary, and question-asking moves visible before asking students to write.</a:t>
+              <a:t>Think aloud: make the reading, visual-analysis, vocabulary, and question-asking moves visible before students explain.</a:t>
             </a:r>
             <a:endParaRPr lang="en-US" sz="2000" dirty="0"/>
           </a:p>
@@ -4128,7 +4128,7 @@
                 <a:ea typeface="Inter" pitchFamily="34" charset="-122"/>
                 <a:cs typeface="Inter" pitchFamily="34" charset="-120"/>
               </a:rPr>
-              <a:t>Circle the main idea or the part of the source that names the central question, claim, or phenomenon.</a:t>
+              <a:t>Circle the central question, phenomenon, pattern, relationship, or claim the source helps students investigate.</a:t>
             </a:r>
             <a:endParaRPr lang="en-US" sz="2100" dirty="0"/>
           </a:p>
@@ -4218,7 +4218,7 @@
                 <a:ea typeface="Inter" pitchFamily="34" charset="-122"/>
                 <a:cs typeface="Inter" pitchFamily="34" charset="-120"/>
               </a:rPr>
-              <a:t>Underline supporting details, observations, data, or relationships students may use as evidence.</a:t>
+              <a:t>Underline observations, data, labels, details, or relationships students may use as evidence.</a:t>
             </a:r>
             <a:endParaRPr lang="en-US" sz="2100" dirty="0"/>
           </a:p>
@@ -4308,7 +4308,7 @@
                 <a:ea typeface="Inter" pitchFamily="34" charset="-122"/>
                 <a:cs typeface="Inter" pitchFamily="34" charset="-120"/>
               </a:rPr>
-              <a:t>Box unfamiliar or high-leverage words. Ask: what does this term mean here and why does it matter?</a:t>
+              <a:t>Box unfamiliar or high-leverage words, symbols, units, or labels that students must interpret accurately.</a:t>
             </a:r>
             <a:endParaRPr lang="en-US" sz="2100" dirty="0"/>
           </a:p>
@@ -4398,7 +4398,7 @@
                 <a:ea typeface="Inter" pitchFamily="34" charset="-122"/>
                 <a:cs typeface="Inter" pitchFamily="34" charset="-120"/>
               </a:rPr>
-              <a:t>Summarize the science idea or record the question the source helps answer.</a:t>
+              <a:t>Summarize what the source shows, the question it raises, or the explanation students will need to construct.</a:t>
             </a:r>
             <a:endParaRPr lang="en-US" sz="2100" dirty="0"/>
           </a:p>
@@ -4468,7 +4468,7 @@
                 <a:ea typeface="Inter" pitchFamily="34" charset="-122"/>
                 <a:cs typeface="Inter" pitchFamily="34" charset="-120"/>
               </a:rPr>
-              <a:t> “Read and annotate today’s source. Record any questions you still have on your paper.”</a:t>
+              <a:t> “Annotate today’s source. Record what you notice, what it may mean, and a question you still have.”</a:t>
             </a:r>
             <a:endParaRPr lang="en-US" sz="2000" dirty="0"/>
           </a:p>
@@ -4594,7 +4594,7 @@
         <p:spPr>
           <a:xfrm>
             <a:off x="508000" y="292100"/>
-            <a:ext cx="11811000" cy="482600"/>
+            <a:ext cx="11938000" cy="482600"/>
           </a:xfrm>
           <a:prstGeom prst="rect">
             <a:avLst/>
@@ -4618,7 +4618,7 @@
                 <a:ea typeface="Inter" pitchFamily="34" charset="-122"/>
                 <a:cs typeface="Inter" pitchFamily="34" charset="-120"/>
               </a:rPr>
-              <a:t>Practice CUBS Before Constructing the CER</a:t>
+              <a:t>Practice CUBS, Then Read a Student Writing Sample</a:t>
             </a:r>
             <a:endParaRPr lang="en-US" sz="3000" dirty="0"/>
           </a:p>
@@ -4696,7 +4696,7 @@
                 <a:ea typeface="Inter" pitchFamily="34" charset="-122"/>
                 <a:cs typeface="Inter" pitchFamily="34" charset="-120"/>
               </a:rPr>
-              <a:t>Use the food web and Question 5 from the benchmark as a shared visual/text example. The exact same routine can be used with a science article, data display, model, or investigation result.</a:t>
+              <a:t>Choose a course-relevant source and 1–2 de-identified writing samples. The Biology benchmark is optional; use the routine and samples from your own science classroom.</a:t>
             </a:r>
             <a:endParaRPr lang="en-US" sz="2300" dirty="0"/>
           </a:p>
@@ -4711,7 +4711,7 @@
         <p:spPr>
           <a:xfrm>
             <a:off x="508000" y="2413000"/>
-            <a:ext cx="6604000" cy="4953000"/>
+            <a:ext cx="6731000" cy="4953000"/>
           </a:xfrm>
           <a:prstGeom prst="rect">
             <a:avLst/>
@@ -4727,29 +4727,45 @@
           </a:ln>
         </p:spPr>
       </p:sp>
-      <p:pic>
-        <p:nvPicPr>
-          <p:cNvPr id="7" name="benchmark-practice" descr="preencoded.png">    </p:cNvPr>
-          <p:cNvPicPr>
-            <a:picLocks noChangeAspect="1"/>
-          </p:cNvPicPr>
-          <p:nvPr/>
-        </p:nvPicPr>
-        <p:blipFill>
-          <a:blip r:embed="rId1"/>
-          <a:srcRect l="-38072" r="-38072" t="0" b="0"/>
-          <a:stretch/>
-        </p:blipFill>
-        <p:spPr>
-          <a:xfrm>
-            <a:off x="698500" y="2603500"/>
-            <a:ext cx="6223000" cy="4572000"/>
-          </a:xfrm>
-          <a:prstGeom prst="rect">
-            <a:avLst/>
-          </a:prstGeom>
-        </p:spPr>
-      </p:pic>
+      <p:sp>
+        <p:nvSpPr>
+          <p:cNvPr id="7" name="source-title"/>
+          <p:cNvSpPr/>
+          <p:nvPr/>
+        </p:nvSpPr>
+        <p:spPr>
+          <a:xfrm>
+            <a:off x="889000" y="2781300"/>
+            <a:ext cx="5969000" cy="381000"/>
+          </a:xfrm>
+          <a:prstGeom prst="rect">
+            <a:avLst/>
+          </a:prstGeom>
+          <a:noFill/>
+          <a:ln/>
+        </p:spPr>
+        <p:txBody>
+          <a:bodyPr wrap="square" lIns="0" tIns="0" rIns="0" bIns="0" rtlCol="0" anchor="t"/>
+          <a:lstStyle/>
+          <a:p>
+            <a:pPr algn="l" indent="0" marL="0">
+              <a:buNone/>
+            </a:pPr>
+            <a:r>
+              <a:rPr lang="en-US" altLang="en-US" sz="2500" dirty="0">
+                <a:solidFill>
+                  <a:srgbClr val="3C4043"/>
+                </a:solidFill>
+                <a:latin typeface="Inter" pitchFamily="34" charset="0"/>
+                <a:ea typeface="Inter" pitchFamily="34" charset="-122"/>
+                <a:cs typeface="Inter" pitchFamily="34" charset="-120"/>
+              </a:rPr>
+              <a:t>SELECT A SOURCE + WRITING SAMPLE</a:t>
+            </a:r>
+            <a:endParaRPr lang="en-US" sz="2500" dirty="0"/>
+          </a:p>
+        </p:txBody>
+      </p:sp>
       <p:sp>
         <p:nvSpPr>
           <p:cNvPr id="8" name="calibration-shape-7"/>
@@ -4758,8 +4774,8 @@
         </p:nvSpPr>
         <p:spPr>
           <a:xfrm>
-            <a:off x="7493000" y="2413000"/>
-            <a:ext cx="8255000" cy="4953000"/>
+            <a:off x="889000" y="3479800"/>
+            <a:ext cx="2667000" cy="1270000"/>
           </a:xfrm>
           <a:prstGeom prst="rect">
             <a:avLst/>
@@ -4777,13 +4793,337 @@
       </p:sp>
       <p:sp>
         <p:nvSpPr>
-          <p:cNvPr id="9" name="protocol-title"/>
-          <p:cNvSpPr/>
-          <p:nvPr/>
-        </p:nvSpPr>
-        <p:spPr>
-          <a:xfrm>
-            <a:off x="7874000" y="2781300"/>
+          <p:cNvPr id="9" name="calibration-shape-8"/>
+          <p:cNvSpPr/>
+          <p:nvPr/>
+        </p:nvSpPr>
+        <p:spPr>
+          <a:xfrm>
+            <a:off x="4064000" y="3479800"/>
+            <a:ext cx="2667000" cy="1270000"/>
+          </a:xfrm>
+          <a:prstGeom prst="rect">
+            <a:avLst/>
+          </a:prstGeom>
+          <a:solidFill>
+            <a:srgbClr val="F3F4F6"/>
+          </a:solidFill>
+          <a:ln w="12700">
+            <a:solidFill>
+              <a:srgbClr val="D1D5DB"/>
+            </a:solidFill>
+            <a:prstDash val="solid"/>
+          </a:ln>
+        </p:spPr>
+      </p:sp>
+      <p:sp>
+        <p:nvSpPr>
+          <p:cNvPr id="10" name="calibration-shape-9"/>
+          <p:cNvSpPr/>
+          <p:nvPr/>
+        </p:nvSpPr>
+        <p:spPr>
+          <a:xfrm>
+            <a:off x="889000" y="5207000"/>
+            <a:ext cx="2667000" cy="1270000"/>
+          </a:xfrm>
+          <a:prstGeom prst="rect">
+            <a:avLst/>
+          </a:prstGeom>
+          <a:solidFill>
+            <a:srgbClr val="F3F4F6"/>
+          </a:solidFill>
+          <a:ln w="12700">
+            <a:solidFill>
+              <a:srgbClr val="D1D5DB"/>
+            </a:solidFill>
+            <a:prstDash val="solid"/>
+          </a:ln>
+        </p:spPr>
+      </p:sp>
+      <p:sp>
+        <p:nvSpPr>
+          <p:cNvPr id="11" name="calibration-shape-10"/>
+          <p:cNvSpPr/>
+          <p:nvPr/>
+        </p:nvSpPr>
+        <p:spPr>
+          <a:xfrm>
+            <a:off x="4064000" y="5207000"/>
+            <a:ext cx="2667000" cy="1270000"/>
+          </a:xfrm>
+          <a:prstGeom prst="rect">
+            <a:avLst/>
+          </a:prstGeom>
+          <a:solidFill>
+            <a:srgbClr val="F3F4F6"/>
+          </a:solidFill>
+          <a:ln w="12700">
+            <a:solidFill>
+              <a:srgbClr val="D1D5DB"/>
+            </a:solidFill>
+            <a:prstDash val="solid"/>
+          </a:ln>
+        </p:spPr>
+      </p:sp>
+      <p:sp>
+        <p:nvSpPr>
+          <p:cNvPr id="12" name="source1"/>
+          <p:cNvSpPr/>
+          <p:nvPr/>
+        </p:nvSpPr>
+        <p:spPr>
+          <a:xfrm>
+            <a:off x="1117600" y="3733800"/>
+            <a:ext cx="2209800" cy="762000"/>
+          </a:xfrm>
+          <a:prstGeom prst="rect">
+            <a:avLst/>
+          </a:prstGeom>
+          <a:noFill/>
+          <a:ln/>
+        </p:spPr>
+        <p:txBody>
+          <a:bodyPr wrap="square" lIns="0" tIns="0" rIns="0" bIns="0" rtlCol="0" anchor="ctr"/>
+          <a:lstStyle/>
+          <a:p>
+            <a:pPr algn="ctr" indent="0" marL="0">
+              <a:buNone/>
+            </a:pPr>
+            <a:r>
+              <a:rPr lang="en-US" altLang="en-US" sz="1900" b="1" dirty="0">
+                <a:solidFill>
+                  <a:srgbClr val="C41220"/>
+                </a:solidFill>
+                <a:latin typeface="Inter" pitchFamily="34" charset="0"/>
+                <a:ea typeface="Inter" pitchFamily="34" charset="-122"/>
+                <a:cs typeface="Inter" pitchFamily="34" charset="-120"/>
+              </a:rPr>
+              <a:t>ARTICLE OR TEXT SET</a:t>
+            </a:r>
+            <a:endParaRPr lang="en-US" sz="1900" dirty="0"/>
+          </a:p>
+          <a:p>
+            <a:pPr algn="ctr" indent="0" marL="0">
+              <a:buNone/>
+            </a:pPr>
+            <a:r>
+              <a:rPr lang="en-US" altLang="en-US" sz="1600" dirty="0">
+                <a:solidFill>
+                  <a:srgbClr val="3C4043"/>
+                </a:solidFill>
+                <a:latin typeface="Inter" pitchFamily="34" charset="0"/>
+                <a:ea typeface="Inter" pitchFamily="34" charset="-122"/>
+                <a:cs typeface="Inter" pitchFamily="34" charset="-120"/>
+              </a:rPr>
+              <a:t>explanation, scenario, procedure</a:t>
+            </a:r>
+            <a:endParaRPr lang="en-US" sz="1900" dirty="0"/>
+          </a:p>
+        </p:txBody>
+      </p:sp>
+      <p:sp>
+        <p:nvSpPr>
+          <p:cNvPr id="13" name="source2"/>
+          <p:cNvSpPr/>
+          <p:nvPr/>
+        </p:nvSpPr>
+        <p:spPr>
+          <a:xfrm>
+            <a:off x="4292600" y="3733800"/>
+            <a:ext cx="2209800" cy="762000"/>
+          </a:xfrm>
+          <a:prstGeom prst="rect">
+            <a:avLst/>
+          </a:prstGeom>
+          <a:noFill/>
+          <a:ln/>
+        </p:spPr>
+        <p:txBody>
+          <a:bodyPr wrap="square" lIns="0" tIns="0" rIns="0" bIns="0" rtlCol="0" anchor="ctr"/>
+          <a:lstStyle/>
+          <a:p>
+            <a:pPr algn="ctr" indent="0" marL="0">
+              <a:buNone/>
+            </a:pPr>
+            <a:r>
+              <a:rPr lang="en-US" altLang="en-US" sz="1900" b="1" dirty="0">
+                <a:solidFill>
+                  <a:srgbClr val="C41220"/>
+                </a:solidFill>
+                <a:latin typeface="Inter" pitchFamily="34" charset="0"/>
+                <a:ea typeface="Inter" pitchFamily="34" charset="-122"/>
+                <a:cs typeface="Inter" pitchFamily="34" charset="-120"/>
+              </a:rPr>
+              <a:t>DATA OR GRAPH</a:t>
+            </a:r>
+            <a:endParaRPr lang="en-US" sz="1900" dirty="0"/>
+          </a:p>
+          <a:p>
+            <a:pPr algn="ctr" indent="0" marL="0">
+              <a:buNone/>
+            </a:pPr>
+            <a:r>
+              <a:rPr lang="en-US" altLang="en-US" sz="1600" dirty="0">
+                <a:solidFill>
+                  <a:srgbClr val="3C4043"/>
+                </a:solidFill>
+                <a:latin typeface="Inter" pitchFamily="34" charset="0"/>
+                <a:ea typeface="Inter" pitchFamily="34" charset="-122"/>
+                <a:cs typeface="Inter" pitchFamily="34" charset="-120"/>
+              </a:rPr>
+              <a:t>table, graph, calculation, pattern</a:t>
+            </a:r>
+            <a:endParaRPr lang="en-US" sz="1900" dirty="0"/>
+          </a:p>
+        </p:txBody>
+      </p:sp>
+      <p:sp>
+        <p:nvSpPr>
+          <p:cNvPr id="14" name="source3"/>
+          <p:cNvSpPr/>
+          <p:nvPr/>
+        </p:nvSpPr>
+        <p:spPr>
+          <a:xfrm>
+            <a:off x="1117600" y="5461000"/>
+            <a:ext cx="2209800" cy="762000"/>
+          </a:xfrm>
+          <a:prstGeom prst="rect">
+            <a:avLst/>
+          </a:prstGeom>
+          <a:noFill/>
+          <a:ln/>
+        </p:spPr>
+        <p:txBody>
+          <a:bodyPr wrap="square" lIns="0" tIns="0" rIns="0" bIns="0" rtlCol="0" anchor="ctr"/>
+          <a:lstStyle/>
+          <a:p>
+            <a:pPr algn="ctr" indent="0" marL="0">
+              <a:buNone/>
+            </a:pPr>
+            <a:r>
+              <a:rPr lang="en-US" altLang="en-US" sz="1900" b="1" dirty="0">
+                <a:solidFill>
+                  <a:srgbClr val="C41220"/>
+                </a:solidFill>
+                <a:latin typeface="Inter" pitchFamily="34" charset="0"/>
+                <a:ea typeface="Inter" pitchFamily="34" charset="-122"/>
+                <a:cs typeface="Inter" pitchFamily="34" charset="-120"/>
+              </a:rPr>
+              <a:t>DIAGRAM OR MODEL</a:t>
+            </a:r>
+            <a:endParaRPr lang="en-US" sz="1900" dirty="0"/>
+          </a:p>
+          <a:p>
+            <a:pPr algn="ctr" indent="0" marL="0">
+              <a:buNone/>
+            </a:pPr>
+            <a:r>
+              <a:rPr lang="en-US" altLang="en-US" sz="1600" dirty="0">
+                <a:solidFill>
+                  <a:srgbClr val="3C4043"/>
+                </a:solidFill>
+                <a:latin typeface="Inter" pitchFamily="34" charset="0"/>
+                <a:ea typeface="Inter" pitchFamily="34" charset="-122"/>
+                <a:cs typeface="Inter" pitchFamily="34" charset="-120"/>
+              </a:rPr>
+              <a:t>system, process, particle model</a:t>
+            </a:r>
+            <a:endParaRPr lang="en-US" sz="1900" dirty="0"/>
+          </a:p>
+        </p:txBody>
+      </p:sp>
+      <p:sp>
+        <p:nvSpPr>
+          <p:cNvPr id="15" name="source4"/>
+          <p:cNvSpPr/>
+          <p:nvPr/>
+        </p:nvSpPr>
+        <p:spPr>
+          <a:xfrm>
+            <a:off x="4292600" y="5461000"/>
+            <a:ext cx="2209800" cy="762000"/>
+          </a:xfrm>
+          <a:prstGeom prst="rect">
+            <a:avLst/>
+          </a:prstGeom>
+          <a:noFill/>
+          <a:ln/>
+        </p:spPr>
+        <p:txBody>
+          <a:bodyPr wrap="square" lIns="0" tIns="0" rIns="0" bIns="0" rtlCol="0" anchor="ctr"/>
+          <a:lstStyle/>
+          <a:p>
+            <a:pPr algn="ctr" indent="0" marL="0">
+              <a:buNone/>
+            </a:pPr>
+            <a:r>
+              <a:rPr lang="en-US" altLang="en-US" sz="1900" b="1" dirty="0">
+                <a:solidFill>
+                  <a:srgbClr val="C41220"/>
+                </a:solidFill>
+                <a:latin typeface="Inter" pitchFamily="34" charset="0"/>
+                <a:ea typeface="Inter" pitchFamily="34" charset="-122"/>
+                <a:cs typeface="Inter" pitchFamily="34" charset="-120"/>
+              </a:rPr>
+              <a:t>INVESTIGATION RESULT</a:t>
+            </a:r>
+            <a:endParaRPr lang="en-US" sz="1900" dirty="0"/>
+          </a:p>
+          <a:p>
+            <a:pPr algn="ctr" indent="0" marL="0">
+              <a:buNone/>
+            </a:pPr>
+            <a:r>
+              <a:rPr lang="en-US" altLang="en-US" sz="1600" dirty="0">
+                <a:solidFill>
+                  <a:srgbClr val="3C4043"/>
+                </a:solidFill>
+                <a:latin typeface="Inter" pitchFamily="34" charset="0"/>
+                <a:ea typeface="Inter" pitchFamily="34" charset="-122"/>
+                <a:cs typeface="Inter" pitchFamily="34" charset="-120"/>
+              </a:rPr>
+              <a:t>observation, evidence, conclusion</a:t>
+            </a:r>
+            <a:endParaRPr lang="en-US" sz="1900" dirty="0"/>
+          </a:p>
+        </p:txBody>
+      </p:sp>
+      <p:sp>
+        <p:nvSpPr>
+          <p:cNvPr id="16" name="calibration-shape-15"/>
+          <p:cNvSpPr/>
+          <p:nvPr/>
+        </p:nvSpPr>
+        <p:spPr>
+          <a:xfrm>
+            <a:off x="7620000" y="2413000"/>
+            <a:ext cx="8128000" cy="4953000"/>
+          </a:xfrm>
+          <a:prstGeom prst="rect">
+            <a:avLst/>
+          </a:prstGeom>
+          <a:solidFill>
+            <a:srgbClr val="F3F4F6"/>
+          </a:solidFill>
+          <a:ln w="12700">
+            <a:solidFill>
+              <a:srgbClr val="D1D5DB"/>
+            </a:solidFill>
+            <a:prstDash val="solid"/>
+          </a:ln>
+        </p:spPr>
+      </p:sp>
+      <p:sp>
+        <p:nvSpPr>
+          <p:cNvPr id="17" name="protocol-title"/>
+          <p:cNvSpPr/>
+          <p:nvPr/>
+        </p:nvSpPr>
+        <p:spPr>
+          <a:xfrm>
+            <a:off x="8001000" y="2781300"/>
             <a:ext cx="7239000" cy="381000"/>
           </a:xfrm>
           <a:prstGeom prst="rect">
@@ -4808,7 +5148,7 @@
                 <a:ea typeface="Inter" pitchFamily="34" charset="-122"/>
                 <a:cs typeface="Inter" pitchFamily="34" charset="-120"/>
               </a:rPr>
-              <a:t>PAIR PRACTICE: WHAT WILL STUDENTS NEED TO NOTICE?</a:t>
+              <a:t>PAIR PRACTICE: WHAT MUST STUDENTS NOTICE?</a:t>
             </a:r>
             <a:endParaRPr lang="en-US" sz="2500" dirty="0"/>
           </a:p>
@@ -4816,13 +5156,13 @@
       </p:sp>
       <p:sp>
         <p:nvSpPr>
-          <p:cNvPr id="10" name="protocol"/>
-          <p:cNvSpPr/>
-          <p:nvPr/>
-        </p:nvSpPr>
-        <p:spPr>
-          <a:xfrm>
-            <a:off x="7874000" y="3467100"/>
+          <p:cNvPr id="18" name="protocol"/>
+          <p:cNvSpPr/>
+          <p:nvPr/>
+        </p:nvSpPr>
+        <p:spPr>
+          <a:xfrm>
+            <a:off x="8001000" y="3467100"/>
             <a:ext cx="7112000" cy="3175000"/>
           </a:xfrm>
           <a:prstGeom prst="rect">
@@ -4861,7 +5201,7 @@
                 <a:ea typeface="Inter" pitchFamily="34" charset="-122"/>
                 <a:cs typeface="Inter" pitchFamily="34" charset="-120"/>
               </a:rPr>
-              <a:t> the prediction question and central relationship.</a:t>
+              <a:t> the question, phenomenon, pattern, or relationship students must address.</a:t>
             </a:r>
             <a:endParaRPr lang="en-US" sz="2100" dirty="0"/>
           </a:p>
@@ -4892,7 +5232,7 @@
                 <a:ea typeface="Inter" pitchFamily="34" charset="-122"/>
                 <a:cs typeface="Inter" pitchFamily="34" charset="-120"/>
               </a:rPr>
-              <a:t> the graph and food-web details a student could use as evidence.</a:t>
+              <a:t> details, observations, data, or labels that can serve as evidence.</a:t>
             </a:r>
             <a:endParaRPr lang="en-US" sz="2100" dirty="0"/>
           </a:p>
@@ -4923,7 +5263,7 @@
                 <a:ea typeface="Inter" pitchFamily="34" charset="-122"/>
                 <a:cs typeface="Inter" pitchFamily="34" charset="-120"/>
               </a:rPr>
-              <a:t> terms that could prevent access to the task.</a:t>
+              <a:t> vocabulary, symbols, units, or representations that could limit access.</a:t>
             </a:r>
             <a:endParaRPr lang="en-US" sz="2100" dirty="0"/>
           </a:p>
@@ -4954,7 +5294,7 @@
                 <a:ea typeface="Inter" pitchFamily="34" charset="-122"/>
                 <a:cs typeface="Inter" pitchFamily="34" charset="-120"/>
               </a:rPr>
-              <a:t> the explanation a student will need to construct.</a:t>
+              <a:t> the science explanation, prediction, or conclusion students will need to construct.</a:t>
             </a:r>
             <a:endParaRPr lang="en-US" sz="2100" dirty="0"/>
           </a:p>
@@ -4962,7 +5302,7 @@
       </p:sp>
       <p:sp>
         <p:nvSpPr>
-          <p:cNvPr id="11" name="calibration-shape-10"/>
+          <p:cNvPr id="19" name="calibration-shape-18"/>
           <p:cNvSpPr/>
           <p:nvPr/>
         </p:nvSpPr>
@@ -4982,7 +5322,7 @@
       </p:sp>
       <p:sp>
         <p:nvSpPr>
-          <p:cNvPr id="12" name="transfer"/>
+          <p:cNvPr id="20" name="transfer"/>
           <p:cNvSpPr/>
           <p:nvPr/>
         </p:nvSpPr>
@@ -5024,7 +5364,7 @@
                 <a:ea typeface="Inter" pitchFamily="34" charset="-122"/>
                 <a:cs typeface="Inter" pitchFamily="34" charset="-120"/>
               </a:rPr>
-              <a:t> Which annotation decision will make a stronger student CER more likely? Which question will you ask before students write?</a:t>
+              <a:t> What will you model, what will students annotate, and what does the writing sample show students need next?</a:t>
             </a:r>
             <a:endParaRPr lang="en-US" sz="1800" dirty="0"/>
           </a:p>
@@ -5032,7 +5372,7 @@
       </p:sp>
       <p:sp>
         <p:nvSpPr>
-          <p:cNvPr id="13" name="page"/>
+          <p:cNvPr id="21" name="page"/>
           <p:cNvSpPr/>
           <p:nvPr/>
         </p:nvSpPr>
@@ -5071,7 +5411,7 @@
       </p:sp>
       <p:sp>
         <p:nvSpPr>
-          <p:cNvPr id="14" name="calibration-shape-13"/>
+          <p:cNvPr id="22" name="calibration-shape-21"/>
           <p:cNvSpPr/>
           <p:nvPr/>
         </p:nvSpPr>
@@ -5150,7 +5490,7 @@
         <p:spPr>
           <a:xfrm>
             <a:off x="508000" y="292100"/>
-            <a:ext cx="11430000" cy="482600"/>
+            <a:ext cx="11684000" cy="482600"/>
           </a:xfrm>
           <a:prstGeom prst="rect">
             <a:avLst/>
@@ -5174,7 +5514,7 @@
                 <a:ea typeface="Inter" pitchFamily="34" charset="-122"/>
                 <a:cs typeface="Inter" pitchFamily="34" charset="-120"/>
               </a:rPr>
-              <a:t>Model Color-Coded CER: See the Response Structure</a:t>
+              <a:t>Model Color-Coded CER: Make Explanations Visible</a:t>
             </a:r>
             <a:endParaRPr lang="en-US" sz="3000" dirty="0"/>
           </a:p>
@@ -5252,7 +5592,7 @@
                 <a:ea typeface="Inter" pitchFamily="34" charset="-122"/>
                 <a:cs typeface="Inter" pitchFamily="34" charset="-120"/>
               </a:rPr>
-              <a:t>Color coding is a visibility routine. It helps students identify what each sentence is doing and check whether the explanation includes all of the thinking the task requires.</a:t>
+              <a:t>Use a de-identified writing sample to color-code what is visible. The routine helps students identify what each sentence is doing and check whether an evidence-based explanation includes the thinking the task requires.</a:t>
             </a:r>
             <a:endParaRPr lang="en-US" sz="2300" dirty="0"/>
           </a:p>
@@ -5342,7 +5682,7 @@
                 <a:ea typeface="Inter" pitchFamily="34" charset="-122"/>
                 <a:cs typeface="Inter" pitchFamily="34" charset="-120"/>
               </a:rPr>
-              <a:t>The answer, prediction, conclusion, or explanation that responds to the question.</a:t>
+              <a:t>The answer, prediction, conclusion, or explanation that directly responds to the science question.</a:t>
             </a:r>
             <a:endParaRPr lang="en-US" sz="2100" dirty="0"/>
           </a:p>
@@ -5432,7 +5772,7 @@
                 <a:ea typeface="Inter" pitchFamily="34" charset="-122"/>
                 <a:cs typeface="Inter" pitchFamily="34" charset="-120"/>
               </a:rPr>
-              <a:t>Accurate, relevant details from a text, graph, data set, observation, model, or investigation.</a:t>
+              <a:t>Accurate, relevant details from a text, graph, data set, observation, diagram, model, or investigation.</a:t>
             </a:r>
             <a:endParaRPr lang="en-US" sz="2100" dirty="0"/>
           </a:p>
@@ -5522,7 +5862,7 @@
                 <a:ea typeface="Inter" pitchFamily="34" charset="-122"/>
                 <a:cs typeface="Inter" pitchFamily="34" charset="-120"/>
               </a:rPr>
-              <a:t>The scientific explanation of why the evidence supports the claim.</a:t>
+              <a:t>The scientific explanation of why the evidence supports the claim, using the relevant science idea.</a:t>
             </a:r>
             <a:endParaRPr lang="en-US" sz="2100" dirty="0"/>
           </a:p>
@@ -5910,7 +6250,7 @@
                 <a:ea typeface="Inter" pitchFamily="34" charset="-122"/>
                 <a:cs typeface="Inter" pitchFamily="34" charset="-120"/>
               </a:rPr>
-              <a:t>Agree on one student action after feedback. Use explicit modeling, practice, and a prompt that sends students back to the source and their own response without completing the thinking.</a:t>
+              <a:t>Use a writing sample to agree on one student action after feedback. Model the routine, then use a prompt that sends students back to the source and their own explanation without completing the thinking.</a:t>
             </a:r>
             <a:endParaRPr lang="en-US" sz="2300" dirty="0"/>
           </a:p>
@@ -6066,7 +6406,7 @@
                 <a:ea typeface="Inter" pitchFamily="34" charset="-122"/>
                 <a:cs typeface="Inter" pitchFamily="34" charset="-120"/>
               </a:rPr>
-              <a:t>Model how to use CUBS or identify a CER part.</a:t>
+              <a:t>Model how to interpret a source or identify a CER part.</a:t>
             </a:r>
             <a:endParaRPr lang="en-US" sz="2000" dirty="0"/>
           </a:p>
@@ -6122,7 +6462,7 @@
                 <a:ea typeface="Inter" pitchFamily="34" charset="-122"/>
                 <a:cs typeface="Inter" pitchFamily="34" charset="-120"/>
               </a:rPr>
-              <a:t>Ask students what the source shows and why it matters.</a:t>
+              <a:t>Ask what the source shows, means, or supports.</a:t>
             </a:r>
             <a:endParaRPr lang="en-US" sz="2000" dirty="0"/>
           </a:p>
@@ -6178,7 +6518,7 @@
                 <a:ea typeface="Inter" pitchFamily="34" charset="-122"/>
                 <a:cs typeface="Inter" pitchFamily="34" charset="-120"/>
               </a:rPr>
-              <a:t>Students construct the response and label claim, evidence, and reasoning.</a:t>
+              <a:t>Students construct and label an evidence-based explanation.</a:t>
             </a:r>
             <a:endParaRPr lang="en-US" sz="2000" dirty="0"/>
           </a:p>
@@ -6234,7 +6574,7 @@
                 <a:ea typeface="Inter" pitchFamily="34" charset="-122"/>
                 <a:cs typeface="Inter" pitchFamily="34" charset="-120"/>
               </a:rPr>
-              <a:t>Students act on one calibrated, criterion-based written feedback prompt.</a:t>
+              <a:t>Students act on one calibrated, criterion-based feedback prompt.</a:t>
             </a:r>
             <a:endParaRPr lang="en-US" sz="2000" dirty="0"/>
           </a:p>
@@ -6391,7 +6731,7 @@
         <p:spPr>
           <a:xfrm>
             <a:off x="990600" y="6070600"/>
-            <a:ext cx="6350000" cy="355600"/>
+            <a:ext cx="7112000" cy="355600"/>
           </a:xfrm>
           <a:prstGeom prst="rect">
             <a:avLst/>
@@ -6457,7 +6797,7 @@
                 <a:ea typeface="Inter" pitchFamily="34" charset="-122"/>
                 <a:cs typeface="Inter" pitchFamily="34" charset="-120"/>
               </a:rPr>
-              <a:t>“Underline the evidence you selected. Then add or revise a reasoning sentence that explains how this evidence supports your claim.”</a:t>
+              <a:t>“Underline the evidence you selected. Then add or revise a reasoning sentence that explains how this evidence supports your claim or conclusion.”</a:t>
             </a:r>
             <a:endParaRPr lang="en-US" sz="2100" dirty="0"/>
           </a:p>
@@ -6583,7 +6923,7 @@
         <p:spPr>
           <a:xfrm>
             <a:off x="508000" y="292100"/>
-            <a:ext cx="11430000" cy="482600"/>
+            <a:ext cx="11811000" cy="482600"/>
           </a:xfrm>
           <a:prstGeom prst="rect">
             <a:avLst/>
@@ -6607,7 +6947,7 @@
                 <a:ea typeface="Inter" pitchFamily="34" charset="-122"/>
                 <a:cs typeface="Inter" pitchFamily="34" charset="-120"/>
               </a:rPr>
-              <a:t>Protected Course-Alike Calibration + Application</a:t>
+              <a:t>Teacher Strategy Share + Course-Alike Reflection</a:t>
             </a:r>
             <a:endParaRPr lang="en-US" sz="3000" dirty="0"/>
           </a:p>
@@ -6808,7 +7148,7 @@
                 <a:ea typeface="Inter" pitchFamily="34" charset="-122"/>
                 <a:cs typeface="Inter" pitchFamily="34" charset="-120"/>
               </a:rPr>
-              <a:t>Draft your own student routine first. Then use colleagues to test clarity, rigor, access, and the thinking it requires.</a:t>
+              <a:t>Listen to 2–3 teacher strategy shares first. Then complete the reflection and use colleagues to test clarity, rigor, access, and next steps.</a:t>
             </a:r>
             <a:endParaRPr lang="en-US" sz="2000" dirty="0"/>
           </a:p>
@@ -6875,7 +7215,7 @@
                 <a:ea typeface="Inter" pitchFamily="34" charset="-122"/>
                 <a:cs typeface="Inter" pitchFamily="34" charset="-120"/>
               </a:rPr>
-              <a:t>1. Choose the writing benchmark/source/task.</a:t>
+              <a:t>1. Hear 2–3 teacher strategy shares.</a:t>
             </a:r>
             <a:r>
               <a:rPr lang="en-US" altLang="en-US" sz="2100" dirty="0">
@@ -6886,7 +7226,7 @@
                 <a:ea typeface="Inter" pitchFamily="34" charset="-122"/>
                 <a:cs typeface="Inter" pitchFamily="34" charset="-120"/>
               </a:rPr>
-              <a:t> Use an article, text set, data display, model, investigation prompt, or constructed-response task connected to your current standard.</a:t>
+              <a:t> Listen for a concrete CUBS/CER routine, student direction, access support, or feedback move you can adapt to your own source/task.</a:t>
             </a:r>
             <a:endParaRPr lang="en-US" sz="2100" dirty="0"/>
           </a:p>
@@ -6953,7 +7293,7 @@
                 <a:ea typeface="Inter" pitchFamily="34" charset="-122"/>
                 <a:cs typeface="Inter" pitchFamily="34" charset="-120"/>
               </a:rPr>
-              <a:t>2. Calibrate the student expectations.</a:t>
+              <a:t>2. Read samples against the student routine.</a:t>
             </a:r>
             <a:r>
               <a:rPr lang="en-US" altLang="en-US" sz="2100" dirty="0">
@@ -6964,7 +7304,7 @@
                 <a:ea typeface="Inter" pitchFamily="34" charset="-122"/>
                 <a:cs typeface="Inter" pitchFamily="34" charset="-120"/>
               </a:rPr>
-              <a:t> Specify what students will CUBS, what they will identify or color-code in CER, and what the response must show to meet the mastery bar.</a:t>
+              <a:t> Specify what students will CUBS, what is visible or missing in CER, and what the response must show to meet the mastery bar.</a:t>
             </a:r>
             <a:endParaRPr lang="en-US" sz="2100" dirty="0"/>
           </a:p>
@@ -7004,7 +7344,7 @@
         <p:spPr>
           <a:xfrm>
             <a:off x="5181600" y="5537200"/>
-            <a:ext cx="9842500" cy="1143000"/>
+            <a:ext cx="9842500" cy="1168400"/>
           </a:xfrm>
           <a:prstGeom prst="rect">
             <a:avLst/>
@@ -7031,7 +7371,7 @@
                 <a:ea typeface="Inter" pitchFamily="34" charset="-122"/>
                 <a:cs typeface="Inter" pitchFamily="34" charset="-120"/>
               </a:rPr>
-              <a:t>3. Plan feedback + revision.</a:t>
+              <a:t>3. Complete the reflection sheet during and after PD.</a:t>
             </a:r>
             <a:r>
               <a:rPr lang="en-US" altLang="en-US" sz="2100" dirty="0">
@@ -7042,7 +7382,7 @@
                 <a:ea typeface="Inter" pitchFamily="34" charset="-122"/>
                 <a:cs typeface="Inter" pitchFamily="34" charset="-120"/>
               </a:rPr>
-              <a:t> Name the prompt, partner talk, annotation check, or short response that reveals thinking, then write a criterion-based feedback prompt and the revision students will complete.</a:t>
+              <a:t> Record the LIT-aligned task, anticipated thinking, sample-based feedback prompt, colleague strategy, student revision action, and next evidence check.</a:t>
             </a:r>
             <a:endParaRPr lang="en-US" sz="2100" dirty="0"/>
           </a:p>
@@ -7233,7 +7573,7 @@
                 <a:ea typeface="Inter" pitchFamily="34" charset="-122"/>
                 <a:cs typeface="Inter" pitchFamily="34" charset="-120"/>
               </a:rPr>
-              <a:t>Implement the routine. Collect writing. Revisit feedback and revision Friday.</a:t>
+              <a:t>Adapt the routine. Capture the next step. Revisit student evidence Friday.</a:t>
             </a:r>
             <a:endParaRPr lang="en-US" sz="3900" dirty="0"/>
           </a:p>
@@ -7375,7 +7715,7 @@
                 <a:ea typeface="Inter" pitchFamily="34" charset="-122"/>
                 <a:cs typeface="Inter" pitchFamily="34" charset="-120"/>
               </a:rPr>
-              <a:t>USE</a:t>
+              <a:t>ADAPT</a:t>
             </a:r>
             <a:endParaRPr lang="en-US" sz="2000" dirty="0"/>
           </a:p>
@@ -7398,7 +7738,7 @@
                 <a:ea typeface="Inter" pitchFamily="34" charset="-122"/>
                 <a:cs typeface="Inter" pitchFamily="34" charset="-120"/>
               </a:rPr>
-              <a:t>Teach the CUBS/CER routine with the planned source and writing task.</a:t>
+              <a:t>Teach the CUBS/CER routine with an appropriate course source and response task.</a:t>
             </a:r>
             <a:endParaRPr lang="en-US" sz="2000" dirty="0"/>
           </a:p>
@@ -7440,7 +7780,7 @@
                 <a:ea typeface="Inter" pitchFamily="34" charset="-122"/>
                 <a:cs typeface="Inter" pitchFamily="34" charset="-120"/>
               </a:rPr>
-              <a:t>COLLECT</a:t>
+              <a:t>REFLECT + SHARE</a:t>
             </a:r>
             <a:endParaRPr lang="en-US" sz="2000" dirty="0"/>
           </a:p>
@@ -7463,7 +7803,7 @@
                 <a:ea typeface="Inter" pitchFamily="34" charset="-122"/>
                 <a:cs typeface="Inter" pitchFamily="34" charset="-120"/>
               </a:rPr>
-              <a:t>Bring a small de-identified set of completed writing and the feedback/revision evidence from the task.</a:t>
+              <a:t>Complete the sheet during and after PD: name a sample-based feedback move, one colleague strategy, and the evidence you will collect.</a:t>
             </a:r>
             <a:endParaRPr lang="en-US" sz="2000" dirty="0"/>
           </a:p>
@@ -7528,7 +7868,7 @@
                 <a:ea typeface="Inter" pitchFamily="34" charset="-122"/>
                 <a:cs typeface="Inter" pitchFamily="34" charset="-120"/>
               </a:rPr>
-              <a:t>Use the mastery bar to analyze writing, provide feedback, and plan the next standard-focused step.</a:t>
+              <a:t>Use completed writing and feedback evidence to plan a precise, standard-focused next step.</a:t>
             </a:r>
             <a:endParaRPr lang="en-US" sz="2000" dirty="0"/>
           </a:p>

</xml_diff>

<commit_message>
Align Oct. 28 PD strategy-share materials
Update the PD deck, agenda, and quick planning sheet so teachers may share existing reading/article-analysis or writing strategies, discuss what works and any challenge, or choose a CUBS/CER move to try in an upcoming lesson.
</commit_message>
<xml_diff>
--- a/assets/plc/2026-10-28_Science_Department_PD_Strengthening_Science_Literacy.pptx
+++ b/assets/plc/2026-10-28_Science_Department_PD_Strengthening_Science_Literacy.pptx
@@ -2842,7 +2842,7 @@
                 <a:ea typeface="Inter" pitchFamily="34" charset="-122"/>
                 <a:cs typeface="Inter" pitchFamily="34" charset="-120"/>
               </a:rPr>
-              <a:t>Learn from colleague strategies, read samples, and record a feedback-informed next move.</a:t>
+              <a:t>Share another strategy—or choose a CUBS/CER move to try—then record a next move.</a:t>
             </a:r>
             <a:endParaRPr lang="en-US" sz="2000" dirty="0"/>
           </a:p>
@@ -7148,7 +7148,7 @@
                 <a:ea typeface="Inter" pitchFamily="34" charset="-122"/>
                 <a:cs typeface="Inter" pitchFamily="34" charset="-120"/>
               </a:rPr>
-              <a:t>Listen to 2–3 teacher strategy shares first. Then complete the reflection and use colleagues to test clarity, rigor, access, and next steps.</a:t>
+              <a:t>Share a strategy you use—or choose one from today to try. Borrow one colleague idea.</a:t>
             </a:r>
             <a:endParaRPr lang="en-US" sz="2000" dirty="0"/>
           </a:p>
@@ -7202,12 +7202,12 @@
           <a:p>
             <a:pPr algn="l" indent="0" marL="0">
               <a:lnSpc>
-                <a:spcPts val="2520"/>
+                <a:spcPts val="2124"/>
               </a:lnSpc>
               <a:buNone/>
             </a:pPr>
             <a:r>
-              <a:rPr lang="en-US" altLang="en-US" sz="2100" b="1" dirty="0">
+              <a:rPr lang="en-US" altLang="en-US" sz="1800" b="1" dirty="0">
                 <a:solidFill>
                   <a:srgbClr val="C41220"/>
                 </a:solidFill>
@@ -7215,10 +7215,10 @@
                 <a:ea typeface="Inter" pitchFamily="34" charset="-122"/>
                 <a:cs typeface="Inter" pitchFamily="34" charset="-120"/>
               </a:rPr>
-              <a:t>1. Hear 2–3 teacher strategy shares.</a:t>
-            </a:r>
-            <a:r>
-              <a:rPr lang="en-US" altLang="en-US" sz="2100" dirty="0">
+              <a:t>1. Share or choose a strategy.</a:t>
+            </a:r>
+            <a:r>
+              <a:rPr lang="en-US" altLang="en-US" sz="1800" dirty="0">
                 <a:solidFill>
                   <a:srgbClr val="3C4043"/>
                 </a:solidFill>
@@ -7226,9 +7226,9 @@
                 <a:ea typeface="Inter" pitchFamily="34" charset="-122"/>
                 <a:cs typeface="Inter" pitchFamily="34" charset="-120"/>
               </a:rPr>
-              <a:t> Listen for a concrete CUBS/CER routine, student direction, access support, or feedback move you can adapt to your own source/task.</a:t>
-            </a:r>
-            <a:endParaRPr lang="en-US" sz="2100" dirty="0"/>
+              <a:t> Share another reading/article-analysis or writing strategy you already use: what works and what needs attention? If you do not use one yet, choose a CUBS/CER move from today to try in a next lesson.</a:t>
+            </a:r>
+            <a:endParaRPr lang="en-US" sz="1800" dirty="0"/>
           </a:p>
         </p:txBody>
       </p:sp>
@@ -7358,12 +7358,12 @@
           <a:p>
             <a:pPr algn="l" indent="0" marL="0">
               <a:lnSpc>
-                <a:spcPts val="2520"/>
+                <a:spcPts val="2124"/>
               </a:lnSpc>
               <a:buNone/>
             </a:pPr>
             <a:r>
-              <a:rPr lang="en-US" altLang="en-US" sz="2100" b="1" dirty="0">
+              <a:rPr lang="en-US" altLang="en-US" sz="1800" b="1" dirty="0">
                 <a:solidFill>
                   <a:srgbClr val="C41220"/>
                 </a:solidFill>
@@ -7374,7 +7374,7 @@
               <a:t>3. Complete the reflection sheet during and after PD.</a:t>
             </a:r>
             <a:r>
-              <a:rPr lang="en-US" altLang="en-US" sz="2100" dirty="0">
+              <a:rPr lang="en-US" altLang="en-US" sz="1800" dirty="0">
                 <a:solidFill>
                   <a:srgbClr val="3C4043"/>
                 </a:solidFill>
@@ -7382,9 +7382,9 @@
                 <a:ea typeface="Inter" pitchFamily="34" charset="-122"/>
                 <a:cs typeface="Inter" pitchFamily="34" charset="-120"/>
               </a:rPr>
-              <a:t> Record the LIT-aligned task, anticipated thinking, sample-based feedback prompt, colleague strategy, student revision action, and next evidence check.</a:t>
-            </a:r>
-            <a:endParaRPr lang="en-US" sz="2100" dirty="0"/>
+              <a:t> Record an existing strategy you will share or a CUBS/CER move you will try, what works or needs attention (if applicable), a colleague idea, student revision action, and next evidence check.</a:t>
+            </a:r>
+            <a:endParaRPr lang="en-US" sz="1800" dirty="0"/>
           </a:p>
         </p:txBody>
       </p:sp>
@@ -7767,7 +7767,7 @@
           <a:p>
             <a:pPr algn="l" indent="0" marL="0">
               <a:lnSpc>
-                <a:spcPts val="1680"/>
+                <a:spcPts val="1652"/>
               </a:lnSpc>
               <a:buNone/>
             </a:pPr>
@@ -7782,12 +7782,12 @@
               </a:rPr>
               <a:t>REFLECT + SHARE</a:t>
             </a:r>
-            <a:endParaRPr lang="en-US" sz="2000" dirty="0"/>
+            <a:endParaRPr lang="en-US" sz="1900" dirty="0"/>
           </a:p>
           <a:p>
             <a:pPr algn="l" indent="0" marL="0">
               <a:lnSpc>
-                <a:spcPts val="2400"/>
+                <a:spcPts val="2242"/>
               </a:lnSpc>
               <a:spcBef>
                 <a:spcPts val="900"/>
@@ -7795,7 +7795,7 @@
               <a:buNone/>
             </a:pPr>
             <a:r>
-              <a:rPr lang="en-US" altLang="en-US" sz="2000" b="1" dirty="0">
+              <a:rPr lang="en-US" altLang="en-US" sz="1900" b="1" dirty="0">
                 <a:solidFill>
                   <a:srgbClr val="3C4043"/>
                 </a:solidFill>
@@ -7803,9 +7803,9 @@
                 <a:ea typeface="Inter" pitchFamily="34" charset="-122"/>
                 <a:cs typeface="Inter" pitchFamily="34" charset="-120"/>
               </a:rPr>
-              <a:t>Complete the sheet during and after PD: name a sample-based feedback move, one colleague strategy, and the evidence you will collect.</a:t>
-            </a:r>
-            <a:endParaRPr lang="en-US" sz="2000" dirty="0"/>
+              <a:t>Share another strategy you use—or choose a CUBS/CER move to try—then record one colleague idea and the evidence you will collect.</a:t>
+            </a:r>
+            <a:endParaRPr lang="en-US" sz="1900" dirty="0"/>
           </a:p>
         </p:txBody>
       </p:sp>

</xml_diff>

<commit_message>
Revise Oct. 28 PD lesson-planning materials
Replace the quick planning sheet with a Lesson Planning & Reflection Sheet focused on student analysis strategies, data-based needs, feedback/revision, after-lesson adjustment, and Friday evidence. Align the PD deck and agenda to the same planning cycle.
</commit_message>
<xml_diff>
--- a/assets/plc/2026-10-28_Science_Department_PD_Strengthening_Science_Literacy.pptx
+++ b/assets/plc/2026-10-28_Science_Department_PD_Strengthening_Science_Literacy.pptx
@@ -2819,7 +2819,7 @@
                 <a:ea typeface="Inter" pitchFamily="34" charset="-122"/>
                 <a:cs typeface="Inter" pitchFamily="34" charset="-120"/>
               </a:rPr>
-              <a:t>Share, reflect + commit</a:t>
+              <a:t>Plan, reflect + adjust</a:t>
             </a:r>
             <a:endParaRPr lang="en-US" sz="2000" dirty="0"/>
           </a:p>
@@ -2842,7 +2842,7 @@
                 <a:ea typeface="Inter" pitchFamily="34" charset="-122"/>
                 <a:cs typeface="Inter" pitchFamily="34" charset="-120"/>
               </a:rPr>
-              <a:t>Share another strategy—or choose a CUBS/CER move to try—then record a next move.</a:t>
+              <a:t>Record the priority need, feedback action, and next evidence check.</a:t>
             </a:r>
             <a:endParaRPr lang="en-US" sz="2000" dirty="0"/>
           </a:p>
@@ -6947,7 +6947,7 @@
                 <a:ea typeface="Inter" pitchFamily="34" charset="-122"/>
                 <a:cs typeface="Inter" pitchFamily="34" charset="-120"/>
               </a:rPr>
-              <a:t>Teacher Strategy Share + Course-Alike Reflection</a:t>
+              <a:t>Course-Alike Lesson Planning + Reflection</a:t>
             </a:r>
             <a:endParaRPr lang="en-US" sz="3000" dirty="0"/>
           </a:p>
@@ -7148,7 +7148,7 @@
                 <a:ea typeface="Inter" pitchFamily="34" charset="-122"/>
                 <a:cs typeface="Inter" pitchFamily="34" charset="-120"/>
               </a:rPr>
-              <a:t>Share a strategy you use—or choose one from today to try. Borrow one colleague idea.</a:t>
+              <a:t>Plan the student strategy, priority need, feedback, and next evidence check.</a:t>
             </a:r>
             <a:endParaRPr lang="en-US" sz="2000" dirty="0"/>
           </a:p>
@@ -7215,7 +7215,7 @@
                 <a:ea typeface="Inter" pitchFamily="34" charset="-122"/>
                 <a:cs typeface="Inter" pitchFamily="34" charset="-120"/>
               </a:rPr>
-              <a:t>1. Share or choose a strategy.</a:t>
+              <a:t>1. Name the data-based priority.</a:t>
             </a:r>
             <a:r>
               <a:rPr lang="en-US" altLang="en-US" sz="1800" dirty="0">
@@ -7226,7 +7226,7 @@
                 <a:ea typeface="Inter" pitchFamily="34" charset="-122"/>
                 <a:cs typeface="Inter" pitchFamily="34" charset="-120"/>
               </a:rPr>
-              <a:t> Share another reading/article-analysis or writing strategy you already use: what works and what needs attention? If you do not use one yet, choose a CUBS/CER move from today to try in a next lesson.</a:t>
+              <a:t> Use student work, assessment data, or observation to name where students struggle most: source analysis, claim, evidence, reasoning, vocabulary, clarity, or another need.</a:t>
             </a:r>
             <a:endParaRPr lang="en-US" sz="1800" dirty="0"/>
           </a:p>
@@ -7280,12 +7280,12 @@
           <a:p>
             <a:pPr algn="l" indent="0" marL="0">
               <a:lnSpc>
-                <a:spcPts val="2520"/>
+                <a:spcPts val="2242"/>
               </a:lnSpc>
               <a:buNone/>
             </a:pPr>
             <a:r>
-              <a:rPr lang="en-US" altLang="en-US" sz="2100" b="1" dirty="0">
+              <a:rPr lang="en-US" altLang="en-US" sz="1900" b="1" dirty="0">
                 <a:solidFill>
                   <a:srgbClr val="C41220"/>
                 </a:solidFill>
@@ -7293,10 +7293,10 @@
                 <a:ea typeface="Inter" pitchFamily="34" charset="-122"/>
                 <a:cs typeface="Inter" pitchFamily="34" charset="-120"/>
               </a:rPr>
-              <a:t>2. Read samples against the student routine.</a:t>
-            </a:r>
-            <a:r>
-              <a:rPr lang="en-US" altLang="en-US" sz="2100" dirty="0">
+              <a:t>2. Plan the student experience.</a:t>
+            </a:r>
+            <a:r>
+              <a:rPr lang="en-US" altLang="en-US" sz="1900" dirty="0">
                 <a:solidFill>
                   <a:srgbClr val="3C4043"/>
                 </a:solidFill>
@@ -7304,9 +7304,9 @@
                 <a:ea typeface="Inter" pitchFamily="34" charset="-122"/>
                 <a:cs typeface="Inter" pitchFamily="34" charset="-120"/>
               </a:rPr>
-              <a:t> Specify what students will CUBS, what is visible or missing in CER, and what the response must show to meet the mastery bar.</a:t>
-            </a:r>
-            <a:endParaRPr lang="en-US" sz="2100" dirty="0"/>
+              <a:t> Record the source/task, the strategy students will use to analyze it, what a complete CER response must show, and the feedback/revision action students will take.</a:t>
+            </a:r>
+            <a:endParaRPr lang="en-US" sz="1900" dirty="0"/>
           </a:p>
         </p:txBody>
       </p:sp>
@@ -7371,7 +7371,7 @@
                 <a:ea typeface="Inter" pitchFamily="34" charset="-122"/>
                 <a:cs typeface="Inter" pitchFamily="34" charset="-120"/>
               </a:rPr>
-              <a:t>3. Complete the reflection sheet during and after PD.</a:t>
+              <a:t>3. Complete the Lesson Planning &amp; Reflection Sheet.</a:t>
             </a:r>
             <a:r>
               <a:rPr lang="en-US" altLang="en-US" sz="1800" dirty="0">
@@ -7382,7 +7382,7 @@
                 <a:ea typeface="Inter" pitchFamily="34" charset="-122"/>
                 <a:cs typeface="Inter" pitchFamily="34" charset="-120"/>
               </a:rPr>
-              <a:t> Record an existing strategy you will share or a CUBS/CER move you will try, what works or needs attention (if applicable), a colleague idea, student revision action, and next evidence check.</a:t>
+              <a:t> During PD, plan the lesson and feedback. After the lesson, record what the evidence shows, what to keep or adjust, one colleague idea, and the evidence you will bring Friday.</a:t>
             </a:r>
             <a:endParaRPr lang="en-US" sz="1800" dirty="0"/>
           </a:p>
@@ -7780,7 +7780,7 @@
                 <a:ea typeface="Inter" pitchFamily="34" charset="-122"/>
                 <a:cs typeface="Inter" pitchFamily="34" charset="-120"/>
               </a:rPr>
-              <a:t>REFLECT + SHARE</a:t>
+              <a:t>PLAN + REFLECT</a:t>
             </a:r>
             <a:endParaRPr lang="en-US" sz="1900" dirty="0"/>
           </a:p>
@@ -7803,7 +7803,7 @@
                 <a:ea typeface="Inter" pitchFamily="34" charset="-122"/>
                 <a:cs typeface="Inter" pitchFamily="34" charset="-120"/>
               </a:rPr>
-              <a:t>Share another strategy you use—or choose a CUBS/CER move to try—then record one colleague idea and the evidence you will collect.</a:t>
+              <a:t>Use the Lesson Planning &amp; Reflection Sheet to record the student strategy, data-based need, feedback/revision action, colleague idea, and evidence you will collect.</a:t>
             </a:r>
             <a:endParaRPr lang="en-US" sz="1900" dirty="0"/>
           </a:p>

</xml_diff>

<commit_message>
Refine Oct. 28 PD cover wording
Use concise, professional course-neutral language for the teacher bring list on the first slide.
</commit_message>
<xml_diff>
--- a/assets/plc/2026-10-28_Science_Department_PD_Strengthening_Science_Literacy.pptx
+++ b/assets/plc/2026-10-28_Science_Department_PD_Strengthening_Science_Literacy.pptx
@@ -1947,7 +1947,7 @@
                 <a:ea typeface="Inter" pitchFamily="34" charset="-122"/>
                 <a:cs typeface="Inter" pitchFamily="34" charset="-120"/>
               </a:rPr>
-              <a:t>Bring:</a:t>
+              <a:t>Please bring:</a:t>
             </a:r>
             <a:r>
               <a:rPr lang="en-US" altLang="en-US" sz="2200" dirty="0">
@@ -1958,7 +1958,7 @@
                 <a:ea typeface="Inter" pitchFamily="34" charset="-122"/>
                 <a:cs typeface="Inter" pitchFamily="34" charset="-120"/>
               </a:rPr>
-              <a:t> one course source or task and one de-identified student writing sample. Use a source that students will read, view, or analyze in an upcoming lesson.</a:t>
+              <a:t> one science source or task from an upcoming lesson and one de-identified sample of student writing.</a:t>
             </a:r>
             <a:endParaRPr lang="en-US" sz="2200" dirty="0"/>
           </a:p>

</xml_diff>

<commit_message>
Refine Oct. 28 PD slides
Simplify all slides, add clearer teacher-facing wording, and retain the correct CER color key.
</commit_message>
<xml_diff>
--- a/assets/plc/2026-10-28_Science_Department_PD_Strengthening_Science_Literacy.pptx
+++ b/assets/plc/2026-10-28_Science_Department_PD_Strengthening_Science_Literacy.pptx
@@ -1681,7 +1681,46 @@
         <p:spPr>
           <a:xfrm>
             <a:off x="736600" y="1676400"/>
-            <a:ext cx="10414000" cy="1955800"/>
+            <a:ext cx="10160000" cy="889000"/>
+          </a:xfrm>
+          <a:prstGeom prst="rect">
+            <a:avLst/>
+          </a:prstGeom>
+          <a:noFill/>
+          <a:ln/>
+        </p:spPr>
+        <p:txBody>
+          <a:bodyPr wrap="square" lIns="0" tIns="0" rIns="0" bIns="0" rtlCol="0" anchor="t"/>
+          <a:lstStyle/>
+          <a:p>
+            <a:pPr algn="l" indent="0" marL="0">
+              <a:buNone/>
+            </a:pPr>
+            <a:r>
+              <a:rPr lang="en-US" altLang="en-US" sz="4200" dirty="0">
+                <a:solidFill>
+                  <a:srgbClr val="202124"/>
+                </a:solidFill>
+                <a:latin typeface="Inter" pitchFamily="34" charset="0"/>
+                <a:ea typeface="Inter" pitchFamily="34" charset="-122"/>
+                <a:cs typeface="Inter" pitchFamily="34" charset="-120"/>
+              </a:rPr>
+              <a:t>Strengthening Science Literacy</a:t>
+            </a:r>
+            <a:endParaRPr lang="en-US" sz="4200" dirty="0"/>
+          </a:p>
+        </p:txBody>
+      </p:sp>
+      <p:sp>
+        <p:nvSpPr>
+          <p:cNvPr id="6" name="subtitle"/>
+          <p:cNvSpPr/>
+          <p:nvPr/>
+        </p:nvSpPr>
+        <p:spPr>
+          <a:xfrm>
+            <a:off x="736600" y="2794000"/>
+            <a:ext cx="10414000" cy="1117600"/>
           </a:xfrm>
           <a:prstGeom prst="rect">
             <a:avLst/>
@@ -1695,93 +1734,53 @@
           <a:p>
             <a:pPr algn="l" indent="0" marL="0">
               <a:lnSpc>
-                <a:spcPts val="4028"/>
+                <a:spcPts val="3360"/>
               </a:lnSpc>
               <a:buNone/>
             </a:pPr>
             <a:r>
-              <a:rPr lang="en-US" altLang="en-US" sz="3800" dirty="0">
-                <a:solidFill>
-                  <a:srgbClr val="202124"/>
-                </a:solidFill>
-                <a:latin typeface="Inter" pitchFamily="34" charset="0"/>
-                <a:ea typeface="Inter" pitchFamily="34" charset="-122"/>
-                <a:cs typeface="Inter" pitchFamily="34" charset="-120"/>
-              </a:rPr>
-              <a:t>Strengthening Science Literacy:</a:t>
-            </a:r>
-            <a:endParaRPr lang="en-US" sz="3800" dirty="0"/>
-          </a:p>
+              <a:rPr lang="en-US" altLang="en-US" sz="2800" dirty="0">
+                <a:solidFill>
+                  <a:srgbClr val="343A40"/>
+                </a:solidFill>
+                <a:latin typeface="Inter" pitchFamily="34" charset="0"/>
+                <a:ea typeface="Inter" pitchFamily="34" charset="-122"/>
+                <a:cs typeface="Inter" pitchFamily="34" charset="-120"/>
+              </a:rPr>
+              <a:t>Calibrating Writing Benchmarks, Feedback, and Revision</a:t>
+            </a:r>
+            <a:endParaRPr lang="en-US" sz="2800" dirty="0"/>
+          </a:p>
+        </p:txBody>
+      </p:sp>
+      <p:sp>
+        <p:nvSpPr>
+          <p:cNvPr id="7" name="purpose"/>
+          <p:cNvSpPr/>
+          <p:nvPr/>
+        </p:nvSpPr>
+        <p:spPr>
+          <a:xfrm>
+            <a:off x="736600" y="4191000"/>
+            <a:ext cx="10033000" cy="1168400"/>
+          </a:xfrm>
+          <a:prstGeom prst="rect">
+            <a:avLst/>
+          </a:prstGeom>
+          <a:noFill/>
+          <a:ln/>
+        </p:spPr>
+        <p:txBody>
+          <a:bodyPr wrap="square" lIns="0" tIns="0" rIns="0" bIns="0" rtlCol="0" anchor="t"/>
+          <a:lstStyle/>
           <a:p>
             <a:pPr algn="l" indent="0" marL="0">
               <a:lnSpc>
-                <a:spcPts val="4028"/>
+                <a:spcPts val="3000"/>
               </a:lnSpc>
               <a:buNone/>
             </a:pPr>
             <a:r>
-              <a:rPr lang="en-US" altLang="en-US" sz="3800" dirty="0">
-                <a:solidFill>
-                  <a:srgbClr val="202124"/>
-                </a:solidFill>
-                <a:latin typeface="Inter" pitchFamily="34" charset="0"/>
-                <a:ea typeface="Inter" pitchFamily="34" charset="-122"/>
-                <a:cs typeface="Inter" pitchFamily="34" charset="-120"/>
-              </a:rPr>
-              <a:t>Calibrating Writing Benchmarks,</a:t>
-            </a:r>
-            <a:endParaRPr lang="en-US" sz="3800" dirty="0"/>
-          </a:p>
-          <a:p>
-            <a:pPr algn="l" indent="0" marL="0">
-              <a:lnSpc>
-                <a:spcPts val="4028"/>
-              </a:lnSpc>
-              <a:buNone/>
-            </a:pPr>
-            <a:r>
-              <a:rPr lang="en-US" altLang="en-US" sz="3800" dirty="0">
-                <a:solidFill>
-                  <a:srgbClr val="202124"/>
-                </a:solidFill>
-                <a:latin typeface="Inter" pitchFamily="34" charset="0"/>
-                <a:ea typeface="Inter" pitchFamily="34" charset="-122"/>
-                <a:cs typeface="Inter" pitchFamily="34" charset="-120"/>
-              </a:rPr>
-              <a:t>Feedback, and Revision</a:t>
-            </a:r>
-            <a:endParaRPr lang="en-US" sz="3800" dirty="0"/>
-          </a:p>
-        </p:txBody>
-      </p:sp>
-      <p:sp>
-        <p:nvSpPr>
-          <p:cNvPr id="6" name="subtitle"/>
-          <p:cNvSpPr/>
-          <p:nvPr/>
-        </p:nvSpPr>
-        <p:spPr>
-          <a:xfrm>
-            <a:off x="736600" y="4013200"/>
-            <a:ext cx="9906000" cy="1016000"/>
-          </a:xfrm>
-          <a:prstGeom prst="rect">
-            <a:avLst/>
-          </a:prstGeom>
-          <a:noFill/>
-          <a:ln/>
-        </p:spPr>
-        <p:txBody>
-          <a:bodyPr wrap="square" lIns="0" tIns="0" rIns="0" bIns="0" rtlCol="0" anchor="t"/>
-          <a:lstStyle/>
-          <a:p>
-            <a:pPr algn="l" indent="0" marL="0">
-              <a:lnSpc>
-                <a:spcPts val="2928"/>
-              </a:lnSpc>
-              <a:buNone/>
-            </a:pPr>
-            <a:r>
               <a:rPr lang="en-US" altLang="en-US" sz="2400" dirty="0">
                 <a:solidFill>
                   <a:srgbClr val="343A40"/>
@@ -1790,7 +1789,7 @@
                 <a:ea typeface="Inter" pitchFamily="34" charset="-122"/>
                 <a:cs typeface="Inter" pitchFamily="34" charset="-120"/>
               </a:rPr>
-              <a:t>A simple routine for helping students read a science source, write an explanation, and revise their thinking.</a:t>
+              <a:t>Today’s focus: help students analyze a science source, write a color-coded CER, use feedback, and revise.</a:t>
             </a:r>
             <a:endParaRPr lang="en-US" sz="2400" dirty="0"/>
           </a:p>
@@ -1798,7 +1797,7 @@
       </p:sp>
       <p:sp>
         <p:nvSpPr>
-          <p:cNvPr id="7" name="cover-shape-6"/>
+          <p:cNvPr id="8" name="cover-shape-7"/>
           <p:cNvSpPr/>
           <p:nvPr/>
         </p:nvSpPr>
@@ -1823,7 +1822,7 @@
       </p:sp>
       <p:sp>
         <p:nvSpPr>
-          <p:cNvPr id="8" name="today"/>
+          <p:cNvPr id="9" name="today"/>
           <p:cNvSpPr/>
           <p:nvPr/>
         </p:nvSpPr>
@@ -1857,7 +1856,7 @@
                 <a:ea typeface="Inter" pitchFamily="34" charset="-122"/>
                 <a:cs typeface="Inter" pitchFamily="34" charset="-120"/>
               </a:rPr>
-              <a:t>TODAY'S GOAL</a:t>
+              <a:t>TODAY'S OUTCOME</a:t>
             </a:r>
             <a:endParaRPr lang="en-US" sz="2300" dirty="0"/>
           </a:p>
@@ -1880,7 +1879,7 @@
                 <a:ea typeface="Inter" pitchFamily="34" charset="-122"/>
                 <a:cs typeface="Inter" pitchFamily="34" charset="-120"/>
               </a:rPr>
-              <a:t>Leave with one simple strategy to use with your students.</a:t>
+              <a:t>Leave with one clear routine to use in an upcoming lesson.</a:t>
             </a:r>
             <a:endParaRPr lang="en-US" sz="2300" dirty="0"/>
           </a:p>
@@ -1888,7 +1887,7 @@
       </p:sp>
       <p:sp>
         <p:nvSpPr>
-          <p:cNvPr id="9" name="cover-shape-8"/>
+          <p:cNvPr id="10" name="cover-shape-9"/>
           <p:cNvSpPr/>
           <p:nvPr/>
         </p:nvSpPr>
@@ -1913,7 +1912,7 @@
       </p:sp>
       <p:sp>
         <p:nvSpPr>
-          <p:cNvPr id="10" name="bring"/>
+          <p:cNvPr id="11" name="materials"/>
           <p:cNvSpPr/>
           <p:nvPr/>
         </p:nvSpPr>
@@ -1947,7 +1946,7 @@
                 <a:ea typeface="Inter" pitchFamily="34" charset="-122"/>
                 <a:cs typeface="Inter" pitchFamily="34" charset="-120"/>
               </a:rPr>
-              <a:t>Please bring:</a:t>
+              <a:t>Work with today:</a:t>
             </a:r>
             <a:r>
               <a:rPr lang="en-US" altLang="en-US" sz="2200" dirty="0">
@@ -1958,7 +1957,7 @@
                 <a:ea typeface="Inter" pitchFamily="34" charset="-122"/>
                 <a:cs typeface="Inter" pitchFamily="34" charset="-120"/>
               </a:rPr>
-              <a:t> one science source or task from an upcoming lesson and one de-identified sample of student writing.</a:t>
+              <a:t> an upcoming science source or task  •  one anonymous student response</a:t>
             </a:r>
             <a:endParaRPr lang="en-US" sz="2200" dirty="0"/>
           </a:p>
@@ -1966,7 +1965,7 @@
       </p:sp>
       <p:sp>
         <p:nvSpPr>
-          <p:cNvPr id="11" name="footer"/>
+          <p:cNvPr id="12" name="footer"/>
           <p:cNvSpPr/>
           <p:nvPr/>
         </p:nvSpPr>
@@ -2016,7 +2015,7 @@
       </p:sp>
       <p:sp>
         <p:nvSpPr>
-          <p:cNvPr id="12" name="page"/>
+          <p:cNvPr id="13" name="page"/>
           <p:cNvSpPr/>
           <p:nvPr/>
         </p:nvSpPr>
@@ -2055,7 +2054,7 @@
       </p:sp>
       <p:sp>
         <p:nvSpPr>
-          <p:cNvPr id="13" name="cover-shape-12"/>
+          <p:cNvPr id="14" name="cover-shape-13"/>
           <p:cNvSpPr/>
           <p:nvPr/>
         </p:nvSpPr>
@@ -2158,7 +2157,7 @@
                 <a:ea typeface="Inter" pitchFamily="34" charset="-122"/>
                 <a:cs typeface="Inter" pitchFamily="34" charset="-120"/>
               </a:rPr>
-              <a:t>The Simple Routine for Today</a:t>
+              <a:t>A Practical Outcome for Today</a:t>
             </a:r>
             <a:endParaRPr lang="en-US" sz="3000" dirty="0"/>
           </a:p>
@@ -2236,7 +2235,7 @@
                 <a:ea typeface="Inter" pitchFamily="34" charset="-122"/>
                 <a:cs typeface="Inter" pitchFamily="34" charset="-120"/>
               </a:rPr>
-              <a:t>Students first make sense of a source. Then they use that thinking to write and improve an explanation.</a:t>
+              <a:t>By the end of the session, each teacher will have a simple plan for one upcoming lesson.</a:t>
             </a:r>
             <a:endParaRPr lang="en-US" sz="2400" dirty="0"/>
           </a:p>
@@ -2401,7 +2400,7 @@
                 <a:ea typeface="Inter" pitchFamily="34" charset="-122"/>
                 <a:cs typeface="Inter" pitchFamily="34" charset="-120"/>
               </a:rPr>
-              <a:t>Read the source</a:t>
+              <a:t>Choose a source</a:t>
             </a:r>
             <a:endParaRPr lang="en-US" sz="2300" dirty="0"/>
           </a:p>
@@ -2424,7 +2423,7 @@
                 <a:ea typeface="Inter" pitchFamily="34" charset="-122"/>
                 <a:cs typeface="Inter" pitchFamily="34" charset="-120"/>
               </a:rPr>
-              <a:t>Students notice the important information.</a:t>
+              <a:t>Select what students will read, view, or analyze.</a:t>
             </a:r>
             <a:endParaRPr lang="en-US" sz="2300" dirty="0"/>
           </a:p>
@@ -2489,7 +2488,7 @@
                 <a:ea typeface="Inter" pitchFamily="34" charset="-122"/>
                 <a:cs typeface="Inter" pitchFamily="34" charset="-120"/>
               </a:rPr>
-              <a:t>Write a CER</a:t>
+              <a:t>Plan the routine</a:t>
             </a:r>
             <a:endParaRPr lang="en-US" sz="2300" dirty="0"/>
           </a:p>
@@ -2512,7 +2511,7 @@
                 <a:ea typeface="Inter" pitchFamily="34" charset="-122"/>
                 <a:cs typeface="Inter" pitchFamily="34" charset="-120"/>
               </a:rPr>
-              <a:t>Students explain what the source shows.</a:t>
+              <a:t>Decide what students will do with CUBS and CER.</a:t>
             </a:r>
             <a:endParaRPr lang="en-US" sz="2300" dirty="0"/>
           </a:p>
@@ -2577,7 +2576,7 @@
                 <a:ea typeface="Inter" pitchFamily="34" charset="-122"/>
                 <a:cs typeface="Inter" pitchFamily="34" charset="-120"/>
               </a:rPr>
-              <a:t>Use feedback</a:t>
+              <a:t>Plan feedback</a:t>
             </a:r>
             <a:endParaRPr lang="en-US" sz="2300" dirty="0"/>
           </a:p>
@@ -2600,7 +2599,7 @@
                 <a:ea typeface="Inter" pitchFamily="34" charset="-122"/>
                 <a:cs typeface="Inter" pitchFamily="34" charset="-120"/>
               </a:rPr>
-              <a:t>Students find one part to improve.</a:t>
+              <a:t>Choose one prompt that directs a revision.</a:t>
             </a:r>
             <a:endParaRPr lang="en-US" sz="2300" dirty="0"/>
           </a:p>
@@ -2665,7 +2664,7 @@
                 <a:ea typeface="Inter" pitchFamily="34" charset="-122"/>
                 <a:cs typeface="Inter" pitchFamily="34" charset="-120"/>
               </a:rPr>
-              <a:t>Revise</a:t>
+              <a:t>Check the evidence</a:t>
             </a:r>
             <a:endParaRPr lang="en-US" sz="2300" dirty="0"/>
           </a:p>
@@ -2688,7 +2687,7 @@
                 <a:ea typeface="Inter" pitchFamily="34" charset="-122"/>
                 <a:cs typeface="Inter" pitchFamily="34" charset="-120"/>
               </a:rPr>
-              <a:t>Students add, change, or strengthen their explanation.</a:t>
+              <a:t>Collect student work and use it to plan next steps.</a:t>
             </a:r>
             <a:endParaRPr lang="en-US" sz="2300" dirty="0"/>
           </a:p>
@@ -2739,17 +2738,6 @@
               <a:buNone/>
             </a:pPr>
             <a:r>
-              <a:rPr lang="en-US" altLang="en-US" sz="2100" b="1" dirty="0">
-                <a:solidFill>
-                  <a:srgbClr val="F6B4BA"/>
-                </a:solidFill>
-                <a:latin typeface="Inter" pitchFamily="34" charset="0"/>
-                <a:ea typeface="Inter" pitchFamily="34" charset="-122"/>
-                <a:cs typeface="Inter" pitchFamily="34" charset="-120"/>
-              </a:rPr>
-              <a:t>Important:</a:t>
-            </a:r>
-            <a:r>
               <a:rPr lang="en-US" altLang="en-US" sz="2100" dirty="0">
                 <a:solidFill>
                   <a:srgbClr val="FFFFFF"/>
@@ -2758,7 +2746,7 @@
                 <a:ea typeface="Inter" pitchFamily="34" charset="-122"/>
                 <a:cs typeface="Inter" pitchFamily="34" charset="-120"/>
               </a:rPr>
-              <a:t> The routine supports student thinking. It does not give students the answer.</a:t>
+              <a:t>The routine supports student thinking. It does not give students the answer.</a:t>
             </a:r>
             <a:endParaRPr lang="en-US" sz="2100" dirty="0"/>
           </a:p>
@@ -2908,7 +2896,7 @@
                 <a:ea typeface="Inter" pitchFamily="34" charset="-122"/>
                 <a:cs typeface="Inter" pitchFamily="34" charset="-120"/>
               </a:rPr>
-              <a:t>How This Connects to This Week's PLCs</a:t>
+              <a:t>How Today Connects to This Week</a:t>
             </a:r>
             <a:endParaRPr lang="en-US" sz="3000" dirty="0"/>
           </a:p>
@@ -2986,7 +2974,7 @@
                 <a:ea typeface="Inter" pitchFamily="34" charset="-122"/>
                 <a:cs typeface="Inter" pitchFamily="34" charset="-120"/>
               </a:rPr>
-              <a:t>The same simple question guides the week: What are students doing, and what will help them meet the standard?</a:t>
+              <a:t>The goal is one continuous cycle: prepare students, study their work, and respond to what the evidence shows.</a:t>
             </a:r>
             <a:endParaRPr lang="en-US" sz="2400" dirty="0"/>
           </a:p>
@@ -3146,7 +3134,7 @@
                 <a:ea typeface="Inter" pitchFamily="34" charset="-122"/>
                 <a:cs typeface="Inter" pitchFamily="34" charset="-120"/>
               </a:rPr>
-              <a:t>Teachers did the task.</a:t>
+              <a:t>Rehearse the task</a:t>
             </a:r>
             <a:endParaRPr lang="en-US" sz="2300" dirty="0"/>
           </a:p>
@@ -3169,7 +3157,7 @@
                 <a:ea typeface="Inter" pitchFamily="34" charset="-122"/>
                 <a:cs typeface="Inter" pitchFamily="34" charset="-120"/>
               </a:rPr>
-              <a:t>What might students find hard?</a:t>
+              <a:t>Anticipate student thinking and common errors.</a:t>
             </a:r>
             <a:endParaRPr lang="en-US" sz="2300" dirty="0"/>
           </a:p>
@@ -3234,7 +3222,7 @@
                 <a:ea typeface="Inter" pitchFamily="34" charset="-122"/>
                 <a:cs typeface="Inter" pitchFamily="34" charset="-120"/>
               </a:rPr>
-              <a:t>Teachers planned support.</a:t>
+              <a:t>Plan the lesson</a:t>
             </a:r>
             <a:endParaRPr lang="en-US" sz="2300" dirty="0"/>
           </a:p>
@@ -3257,7 +3245,7 @@
                 <a:ea typeface="Inter" pitchFamily="34" charset="-122"/>
                 <a:cs typeface="Inter" pitchFamily="34" charset="-120"/>
               </a:rPr>
-              <a:t>What will students do, say, and write?</a:t>
+              <a:t>Plan supports, feedback, and student revision.</a:t>
             </a:r>
             <a:endParaRPr lang="en-US" sz="2300" dirty="0"/>
           </a:p>
@@ -3322,7 +3310,7 @@
                 <a:ea typeface="Inter" pitchFamily="34" charset="-122"/>
                 <a:cs typeface="Inter" pitchFamily="34" charset="-120"/>
               </a:rPr>
-              <a:t>Practice the routine.</a:t>
+              <a:t>Build the routine</a:t>
             </a:r>
             <a:endParaRPr lang="en-US" sz="2300" dirty="0"/>
           </a:p>
@@ -3345,7 +3333,7 @@
                 <a:ea typeface="Inter" pitchFamily="34" charset="-122"/>
                 <a:cs typeface="Inter" pitchFamily="34" charset="-120"/>
               </a:rPr>
-              <a:t>How will CUBS and CER help students?</a:t>
+              <a:t>Use CUBS and CER to make thinking visible.</a:t>
             </a:r>
             <a:endParaRPr lang="en-US" sz="2300" dirty="0"/>
           </a:p>
@@ -3410,7 +3398,7 @@
                 <a:ea typeface="Inter" pitchFamily="34" charset="-122"/>
                 <a:cs typeface="Inter" pitchFamily="34" charset="-120"/>
               </a:rPr>
-              <a:t>Read student work.</a:t>
+              <a:t>Study student work</a:t>
             </a:r>
             <a:endParaRPr lang="en-US" sz="2300" dirty="0"/>
           </a:p>
@@ -3433,7 +3421,7 @@
                 <a:ea typeface="Inter" pitchFamily="34" charset="-122"/>
                 <a:cs typeface="Inter" pitchFamily="34" charset="-120"/>
               </a:rPr>
-              <a:t>What should students revise or learn next?</a:t>
+              <a:t>Use evidence to decide the next learning step.</a:t>
             </a:r>
             <a:endParaRPr lang="en-US" sz="2300" dirty="0"/>
           </a:p>
@@ -3497,7 +3485,7 @@
                 <a:ea typeface="Inter" pitchFamily="34" charset="-122"/>
                 <a:cs typeface="Inter" pitchFamily="34" charset="-120"/>
               </a:rPr>
-              <a:t>Use the same routine in every science course. Change the source—not the student-thinking goal.</a:t>
+              <a:t>Use the same thinking process in every science course. The source may change; the learning goal does not.</a:t>
             </a:r>
             <a:endParaRPr lang="en-US" sz="2200" dirty="0"/>
           </a:p>
@@ -3647,7 +3635,7 @@
                 <a:ea typeface="Inter" pitchFamily="34" charset="-122"/>
                 <a:cs typeface="Inter" pitchFamily="34" charset="-120"/>
               </a:rPr>
-              <a:t>CUBS: A Simple Way to Read a Science Source</a:t>
+              <a:t>CUBS: A Routine for Reading a Science Source</a:t>
             </a:r>
             <a:endParaRPr lang="en-US" sz="3000" dirty="0"/>
           </a:p>
@@ -3725,7 +3713,7 @@
                 <a:ea typeface="Inter" pitchFamily="34" charset="-122"/>
                 <a:cs typeface="Inter" pitchFamily="34" charset="-120"/>
               </a:rPr>
-              <a:t>Use CUBS before students write. It helps them slow down and find the information they will need.</a:t>
+              <a:t>Use CUBS before students write. It helps them identify the information they will use in an explanation.</a:t>
             </a:r>
             <a:endParaRPr lang="en-US" sz="2400" dirty="0"/>
           </a:p>
@@ -3913,7 +3901,7 @@
                 <a:ea typeface="Inter" pitchFamily="34" charset="-122"/>
                 <a:cs typeface="Inter" pitchFamily="34" charset="-120"/>
               </a:rPr>
-              <a:t>Circle the question students need to answer.</a:t>
+              <a:t>Circle the question you need to answer.</a:t>
             </a:r>
             <a:endParaRPr lang="en-US" sz="2400" dirty="0"/>
           </a:p>
@@ -4001,7 +3989,7 @@
                 <a:ea typeface="Inter" pitchFamily="34" charset="-122"/>
                 <a:cs typeface="Inter" pitchFamily="34" charset="-120"/>
               </a:rPr>
-              <a:t>Underline details, data, or observations.</a:t>
+              <a:t>Underline details, data, and observations.</a:t>
             </a:r>
             <a:endParaRPr lang="en-US" sz="2400" dirty="0"/>
           </a:p>
@@ -4089,7 +4077,7 @@
                 <a:ea typeface="Inter" pitchFamily="34" charset="-122"/>
                 <a:cs typeface="Inter" pitchFamily="34" charset="-120"/>
               </a:rPr>
-              <a:t>Box words, units, or labels that need attention.</a:t>
+              <a:t>Box key words, units, labels, or ideas.</a:t>
             </a:r>
             <a:endParaRPr lang="en-US" sz="2400" dirty="0"/>
           </a:p>
@@ -4228,17 +4216,6 @@
               <a:buNone/>
             </a:pPr>
             <a:r>
-              <a:rPr lang="en-US" altLang="en-US" sz="2100" b="1" dirty="0">
-                <a:solidFill>
-                  <a:srgbClr val="F6B4BA"/>
-                </a:solidFill>
-                <a:latin typeface="Inter" pitchFamily="34" charset="0"/>
-                <a:ea typeface="Inter" pitchFamily="34" charset="-122"/>
-                <a:cs typeface="Inter" pitchFamily="34" charset="-120"/>
-              </a:rPr>
-              <a:t>Student direction:</a:t>
-            </a:r>
-            <a:r>
               <a:rPr lang="en-US" altLang="en-US" sz="2100" dirty="0">
                 <a:solidFill>
                   <a:srgbClr val="FFFFFF"/>
@@ -4247,7 +4224,7 @@
                 <a:ea typeface="Inter" pitchFamily="34" charset="-122"/>
                 <a:cs typeface="Inter" pitchFamily="34" charset="-120"/>
               </a:rPr>
-              <a:t> “Use CUBS on the source. Then use your notes to help you write.”</a:t>
+              <a:t>Student direction: “Use CUBS on the source. Then use your notes to help you write.”</a:t>
             </a:r>
             <a:endParaRPr lang="en-US" sz="2100" dirty="0"/>
           </a:p>
@@ -4397,7 +4374,7 @@
                 <a:ea typeface="Inter" pitchFamily="34" charset="-122"/>
                 <a:cs typeface="Inter" pitchFamily="34" charset="-120"/>
               </a:rPr>
-              <a:t>Try CUBS With a Source From Your Course</a:t>
+              <a:t>Model It Briefly, Then Let Students Do It</a:t>
             </a:r>
             <a:endParaRPr lang="en-US" sz="3000" dirty="0"/>
           </a:p>
@@ -4475,7 +4452,7 @@
                 <a:ea typeface="Inter" pitchFamily="34" charset="-122"/>
                 <a:cs typeface="Inter" pitchFamily="34" charset="-120"/>
               </a:rPr>
-              <a:t>Choose a text, graph, data set, diagram, model, or investigation result that students will use in an upcoming lesson.</a:t>
+              <a:t>Use an upcoming science source. The routine can work with text, data, diagrams, models, or investigation results.</a:t>
             </a:r>
             <a:endParaRPr lang="en-US" sz="2400" dirty="0"/>
           </a:p>
@@ -4592,7 +4569,7 @@
                 <a:ea typeface="Inter" pitchFamily="34" charset="-122"/>
                 <a:cs typeface="Inter" pitchFamily="34" charset="-120"/>
               </a:rPr>
-              <a:t>1. PICK A SOURCE</a:t>
+              <a:t>1. CHOOSE</a:t>
             </a:r>
             <a:endParaRPr lang="en-US" sz="2500" dirty="0"/>
           </a:p>
@@ -4657,7 +4634,7 @@
                 <a:ea typeface="Inter" pitchFamily="34" charset="-122"/>
                 <a:cs typeface="Inter" pitchFamily="34" charset="-120"/>
               </a:rPr>
-              <a:t>2. DO CUBS</a:t>
+              <a:t>2. MODEL ONE MOVE</a:t>
             </a:r>
             <a:endParaRPr lang="en-US" sz="2500" dirty="0"/>
           </a:p>
@@ -4680,7 +4657,7 @@
                 <a:ea typeface="Inter" pitchFamily="34" charset="-122"/>
                 <a:cs typeface="Inter" pitchFamily="34" charset="-120"/>
               </a:rPr>
-              <a:t>What should students circle, underline, box, and summarize?</a:t>
+              <a:t>Show one CUBS action. Name what you are noticing.</a:t>
             </a:r>
             <a:endParaRPr lang="en-US" sz="2500" dirty="0"/>
           </a:p>
@@ -4722,7 +4699,7 @@
                 <a:ea typeface="Inter" pitchFamily="34" charset="-122"/>
                 <a:cs typeface="Inter" pitchFamily="34" charset="-120"/>
               </a:rPr>
-              <a:t>3. TALK WITH A PARTNER</a:t>
+              <a:t>3. RELEASE THE THINKING</a:t>
             </a:r>
             <a:endParaRPr lang="en-US" sz="2500" dirty="0"/>
           </a:p>
@@ -4745,7 +4722,7 @@
                 <a:ea typeface="Inter" pitchFamily="34" charset="-122"/>
                 <a:cs typeface="Inter" pitchFamily="34" charset="-120"/>
               </a:rPr>
-              <a:t>What will students need to notice before they can write?</a:t>
+              <a:t>Students complete CUBS and use their notes to write.</a:t>
             </a:r>
             <a:endParaRPr lang="en-US" sz="2500" dirty="0"/>
           </a:p>
@@ -4804,7 +4781,7 @@
                 <a:ea typeface="Inter" pitchFamily="34" charset="-122"/>
                 <a:cs typeface="Inter" pitchFamily="34" charset="-120"/>
               </a:rPr>
-              <a:t>Keep it simple: model the first step, then let students do the thinking.</a:t>
+              <a:t>Model a small part of the process. Let students do the thinking that follows.</a:t>
             </a:r>
             <a:endParaRPr lang="en-US" sz="2100" dirty="0"/>
           </a:p>
@@ -4954,7 +4931,7 @@
                 <a:ea typeface="Inter" pitchFamily="34" charset="-122"/>
                 <a:cs typeface="Inter" pitchFamily="34" charset="-120"/>
               </a:rPr>
-              <a:t>CER Color Key: Help Students See Their Thinking</a:t>
+              <a:t>Color-Code What Students Have Written</a:t>
             </a:r>
             <a:endParaRPr lang="en-US" sz="3000" dirty="0"/>
           </a:p>
@@ -5032,7 +5009,7 @@
                 <a:ea typeface="Inter" pitchFamily="34" charset="-122"/>
                 <a:cs typeface="Inter" pitchFamily="34" charset="-120"/>
               </a:rPr>
-              <a:t>After students write, have them color-code what is already in their response. Do not color-code what is missing.</a:t>
+              <a:t>After students write, color-code the thinking that is already in the response. Then decide what to strengthen.</a:t>
             </a:r>
             <a:endParaRPr lang="en-US" sz="2400" dirty="0"/>
           </a:p>
@@ -5422,17 +5399,6 @@
               <a:buNone/>
             </a:pPr>
             <a:r>
-              <a:rPr lang="en-US" altLang="en-US" sz="2100" b="1" dirty="0">
-                <a:solidFill>
-                  <a:srgbClr val="F6B4BA"/>
-                </a:solidFill>
-                <a:latin typeface="Inter" pitchFamily="34" charset="0"/>
-                <a:ea typeface="Inter" pitchFamily="34" charset="-122"/>
-                <a:cs typeface="Inter" pitchFamily="34" charset="-120"/>
-              </a:rPr>
-              <a:t>Student check:</a:t>
-            </a:r>
-            <a:r>
               <a:rPr lang="en-US" altLang="en-US" sz="2100" dirty="0">
                 <a:solidFill>
                   <a:srgbClr val="FFFFFF"/>
@@ -5441,7 +5407,7 @@
                 <a:ea typeface="Inter" pitchFamily="34" charset="-122"/>
                 <a:cs typeface="Inter" pitchFamily="34" charset="-120"/>
               </a:rPr>
-              <a:t> “What color is missing or needs to be stronger?”</a:t>
+              <a:t>Student check: “Which part needs to be added or made stronger?”</a:t>
             </a:r>
             <a:endParaRPr lang="en-US" sz="2100" dirty="0"/>
           </a:p>
@@ -5591,7 +5557,7 @@
                 <a:ea typeface="Inter" pitchFamily="34" charset="-122"/>
                 <a:cs typeface="Inter" pitchFamily="34" charset="-120"/>
               </a:rPr>
-              <a:t>Feedback Should Tell Students What to Do Next</a:t>
+              <a:t>Feedback That Leads to Revision</a:t>
             </a:r>
             <a:endParaRPr lang="en-US" sz="3000" dirty="0"/>
           </a:p>
@@ -5669,7 +5635,7 @@
                 <a:ea typeface="Inter" pitchFamily="34" charset="-122"/>
                 <a:cs typeface="Inter" pitchFamily="34" charset="-120"/>
               </a:rPr>
-              <a:t>Choose one part of the response to improve. Then give students a clear action—not the answer.</a:t>
+              <a:t>Keep feedback short, specific, and connected to one action the student can complete.</a:t>
             </a:r>
             <a:endParaRPr lang="en-US" sz="2400" dirty="0"/>
           </a:p>
@@ -5809,7 +5775,7 @@
                 <a:ea typeface="Inter" pitchFamily="34" charset="-122"/>
                 <a:cs typeface="Inter" pitchFamily="34" charset="-120"/>
               </a:rPr>
-              <a:t>What is missing or weak: claim, evidence, or reasoning?</a:t>
+              <a:t>Identify one part that is missing or needs to be stronger.</a:t>
             </a:r>
             <a:endParaRPr lang="en-US" sz="2500" dirty="0"/>
           </a:p>
@@ -5851,7 +5817,7 @@
                 <a:ea typeface="Inter" pitchFamily="34" charset="-122"/>
                 <a:cs typeface="Inter" pitchFamily="34" charset="-120"/>
               </a:rPr>
-              <a:t>2. PROMPT</a:t>
+              <a:t>2. ASK</a:t>
             </a:r>
             <a:endParaRPr lang="en-US" sz="2500" dirty="0"/>
           </a:p>
@@ -5874,7 +5840,7 @@
                 <a:ea typeface="Inter" pitchFamily="34" charset="-122"/>
                 <a:cs typeface="Inter" pitchFamily="34" charset="-120"/>
               </a:rPr>
-              <a:t>Ask a question that sends students back to the source.</a:t>
+              <a:t>Ask a question that sends students back to their source or response.</a:t>
             </a:r>
             <a:endParaRPr lang="en-US" sz="2500" dirty="0"/>
           </a:p>
@@ -5939,7 +5905,7 @@
                 <a:ea typeface="Inter" pitchFamily="34" charset="-122"/>
                 <a:cs typeface="Inter" pitchFamily="34" charset="-120"/>
               </a:rPr>
-              <a:t>Students add or improve one part of their own response.</a:t>
+              <a:t>Students add, change, or explain one part of their own writing.</a:t>
             </a:r>
             <a:endParaRPr lang="en-US" sz="2500" dirty="0"/>
           </a:p>
@@ -6017,7 +5983,7 @@
                 <a:ea typeface="Inter" pitchFamily="34" charset="-122"/>
                 <a:cs typeface="Inter" pitchFamily="34" charset="-120"/>
               </a:rPr>
-              <a:t> “Find your green evidence. Add a blue sentence that explains why it supports your claim.”</a:t>
+              <a:t> “Find your green evidence. Add a blue sentence that explains how it supports your pink claim.”</a:t>
             </a:r>
             <a:endParaRPr lang="en-US" sz="2200" dirty="0"/>
           </a:p>
@@ -6167,7 +6133,7 @@
                 <a:ea typeface="Inter" pitchFamily="34" charset="-122"/>
                 <a:cs typeface="Inter" pitchFamily="34" charset="-120"/>
               </a:rPr>
-              <a:t>Planning Time: Make This Work in Your Course</a:t>
+              <a:t>Planning Time: Use the Routine in Your Course</a:t>
             </a:r>
             <a:endParaRPr lang="en-US" sz="3000" dirty="0"/>
           </a:p>
@@ -6441,7 +6407,7 @@
                 <a:ea typeface="Inter" pitchFamily="34" charset="-122"/>
                 <a:cs typeface="Inter" pitchFamily="34" charset="-120"/>
               </a:rPr>
-              <a:t>1. What source will students analyze?</a:t>
+              <a:t>1. Choose the source.</a:t>
             </a:r>
             <a:r>
               <a:rPr lang="en-US" altLang="en-US" sz="2400" dirty="0">
@@ -6452,7 +6418,7 @@
                 <a:ea typeface="Inter" pitchFamily="34" charset="-122"/>
                 <a:cs typeface="Inter" pitchFamily="34" charset="-120"/>
               </a:rPr>
-              <a:t> Choose the text, graph, model, data set, or investigation result.</a:t>
+              <a:t> What will students read, view, or analyze?</a:t>
             </a:r>
             <a:endParaRPr lang="en-US" sz="2400" dirty="0"/>
           </a:p>
@@ -6494,7 +6460,7 @@
                 <a:ea typeface="Inter" pitchFamily="34" charset="-122"/>
                 <a:cs typeface="Inter" pitchFamily="34" charset="-120"/>
               </a:rPr>
-              <a:t>2. What will students do?</a:t>
+              <a:t>2. Choose the student moves.</a:t>
             </a:r>
             <a:r>
               <a:rPr lang="en-US" altLang="en-US" sz="2400" dirty="0">
@@ -6505,7 +6471,7 @@
                 <a:ea typeface="Inter" pitchFamily="34" charset="-122"/>
                 <a:cs typeface="Inter" pitchFamily="34" charset="-120"/>
               </a:rPr>
-              <a:t> Choose one CUBS move and one CER expectation.</a:t>
+              <a:t> What will students do with CUBS and CER?</a:t>
             </a:r>
             <a:endParaRPr lang="en-US" sz="2400" dirty="0"/>
           </a:p>
@@ -6547,7 +6513,7 @@
                 <a:ea typeface="Inter" pitchFamily="34" charset="-122"/>
                 <a:cs typeface="Inter" pitchFamily="34" charset="-120"/>
               </a:rPr>
-              <a:t>3. What will students revise?</a:t>
+              <a:t>3. Choose the next step.</a:t>
             </a:r>
             <a:r>
               <a:rPr lang="en-US" altLang="en-US" sz="2400" dirty="0">
@@ -6558,7 +6524,7 @@
                 <a:ea typeface="Inter" pitchFamily="34" charset="-122"/>
                 <a:cs typeface="Inter" pitchFamily="34" charset="-120"/>
               </a:rPr>
-              <a:t> Plan one feedback prompt and one next action. Share one useful idea with a colleague.</a:t>
+              <a:t> What feedback prompt will lead students to revise? Share one useful idea with a colleague.</a:t>
             </a:r>
             <a:endParaRPr lang="en-US" sz="2400" dirty="0"/>
           </a:p>
@@ -6786,7 +6752,7 @@
                 <a:ea typeface="Inter" pitchFamily="34" charset="-122"/>
                 <a:cs typeface="Inter" pitchFamily="34" charset="-120"/>
               </a:rPr>
-              <a:t>Choose one small next step. Bring evidence back on Friday.</a:t>
+              <a:t>Choose one small move to use in an upcoming lesson. Bring the evidence back on Friday.</a:t>
             </a:r>
             <a:endParaRPr lang="en-US" sz="2400" dirty="0"/>
           </a:p>
@@ -6903,7 +6869,7 @@
                 <a:ea typeface="Inter" pitchFamily="34" charset="-122"/>
                 <a:cs typeface="Inter" pitchFamily="34" charset="-120"/>
               </a:rPr>
-              <a:t>1. TEACH</a:t>
+              <a:t>1. USE THE ROUTINE</a:t>
             </a:r>
             <a:endParaRPr lang="en-US" sz="2500" dirty="0"/>
           </a:p>
@@ -6926,7 +6892,7 @@
                 <a:ea typeface="Inter" pitchFamily="34" charset="-122"/>
                 <a:cs typeface="Inter" pitchFamily="34" charset="-120"/>
               </a:rPr>
-              <a:t>Use CUBS or CER with one source in an upcoming lesson.</a:t>
+              <a:t>Use CUBS and/or color-coded CER with one class.</a:t>
             </a:r>
             <a:endParaRPr lang="en-US" sz="2500" dirty="0"/>
           </a:p>
@@ -6968,7 +6934,7 @@
                 <a:ea typeface="Inter" pitchFamily="34" charset="-122"/>
                 <a:cs typeface="Inter" pitchFamily="34" charset="-120"/>
               </a:rPr>
-              <a:t>2. COLLECT</a:t>
+              <a:t>2. SAVE EVIDENCE</a:t>
             </a:r>
             <a:endParaRPr lang="en-US" sz="2500" dirty="0"/>
           </a:p>
@@ -6991,7 +6957,7 @@
                 <a:ea typeface="Inter" pitchFamily="34" charset="-122"/>
                 <a:cs typeface="Inter" pitchFamily="34" charset="-120"/>
               </a:rPr>
-              <a:t>Save one or two de-identified student responses.</a:t>
+              <a:t>Keep one or two anonymous student responses.</a:t>
             </a:r>
             <a:endParaRPr lang="en-US" sz="2500" dirty="0"/>
           </a:p>
@@ -7033,7 +6999,7 @@
                 <a:ea typeface="Inter" pitchFamily="34" charset="-122"/>
                 <a:cs typeface="Inter" pitchFamily="34" charset="-120"/>
               </a:rPr>
-              <a:t>3. BRING FRIDAY</a:t>
+              <a:t>3. PLAN FROM IT</a:t>
             </a:r>
             <a:endParaRPr lang="en-US" sz="2500" dirty="0"/>
           </a:p>
@@ -7056,7 +7022,7 @@
                 <a:ea typeface="Inter" pitchFamily="34" charset="-122"/>
                 <a:cs typeface="Inter" pitchFamily="34" charset="-120"/>
               </a:rPr>
-              <a:t>Bring student work and the feedback you gave.</a:t>
+              <a:t>Use the writing and feedback to decide the next lesson step.</a:t>
             </a:r>
             <a:endParaRPr lang="en-US" sz="2500" dirty="0"/>
           </a:p>
@@ -7107,17 +7073,6 @@
               <a:buNone/>
             </a:pPr>
             <a:r>
-              <a:rPr lang="en-US" altLang="en-US" sz="2100" b="1" dirty="0">
-                <a:solidFill>
-                  <a:srgbClr val="F6B4BA"/>
-                </a:solidFill>
-                <a:latin typeface="Inter" pitchFamily="34" charset="0"/>
-                <a:ea typeface="Inter" pitchFamily="34" charset="-122"/>
-                <a:cs typeface="Inter" pitchFamily="34" charset="-120"/>
-              </a:rPr>
-              <a:t>Remember:</a:t>
-            </a:r>
-            <a:r>
               <a:rPr lang="en-US" altLang="en-US" sz="2100" dirty="0">
                 <a:solidFill>
                   <a:srgbClr val="FFFFFF"/>
@@ -7126,7 +7081,7 @@
                 <a:ea typeface="Inter" pitchFamily="34" charset="-122"/>
                 <a:cs typeface="Inter" pitchFamily="34" charset="-120"/>
               </a:rPr>
-              <a:t> students need practice thinking, writing, and revising—not a completed answer.</a:t>
+              <a:t>Students need practice thinking, writing, receiving feedback, and revising.</a:t>
             </a:r>
             <a:endParaRPr lang="en-US" sz="2100" dirty="0"/>
           </a:p>

</xml_diff>